<commit_message>
refactor: migrate write engine to array-based xml writer
</commit_message>
<xml_diff>
--- a/hokkyss_showcase_deck.pptx
+++ b/hokkyss_showcase_deck.pptx
@@ -1740,7 +1740,7 @@
 </file>
 
 <file path=ppt/notesSlides/notesSlide1.xml><?xml version="1.0" encoding="utf-8"?>
-<p:notes xmlns:a="http://schemas.openxmlformats.org/drawingml/2006/main" xmlns:r="http://schemas.openxmlformats.org/officeDocument/2006/relationships" xmlns:p="http://schemas.openxmlformats.org/presentationml/2006/main">
+<p:notes xmlns:a="http://schemas.openxmlformats.org/drawingml/2006/main" xmlns:p="http://schemas.openxmlformats.org/presentationml/2006/main" xmlns:r="http://schemas.openxmlformats.org/officeDocument/2006/relationships">
   <p:cSld>
     <p:spTree>
       <p:nvGrpSpPr>
@@ -1760,7 +1760,7 @@
         <p:nvSpPr>
           <p:cNvPr id="2" name="Slide Image Placeholder 1"/>
           <p:cNvSpPr>
-            <a:spLocks noGrp="1" noRot="1" noChangeAspect="1"/>
+            <a:spLocks noChangeAspect="1" noGrp="1" noRot="1"/>
           </p:cNvSpPr>
           <p:nvPr>
             <p:ph type="sldImg"/>
@@ -1775,7 +1775,7 @@
             <a:spLocks noGrp="1"/>
           </p:cNvSpPr>
           <p:nvPr>
-            <p:ph type="body" idx="1"/>
+            <p:ph idx="1" type="body"/>
           </p:nvPr>
         </p:nvSpPr>
         <p:spPr/>
@@ -1920,7 +1920,7 @@
 </file>
 
 <file path=ppt/notesSlides/notesSlide10.xml><?xml version="1.0" encoding="utf-8"?>
-<p:notes xmlns:a="http://schemas.openxmlformats.org/drawingml/2006/main" xmlns:r="http://schemas.openxmlformats.org/officeDocument/2006/relationships" xmlns:p="http://schemas.openxmlformats.org/presentationml/2006/main">
+<p:notes xmlns:a="http://schemas.openxmlformats.org/drawingml/2006/main" xmlns:p="http://schemas.openxmlformats.org/presentationml/2006/main" xmlns:r="http://schemas.openxmlformats.org/officeDocument/2006/relationships">
   <p:cSld>
     <p:spTree>
       <p:nvGrpSpPr>
@@ -1940,7 +1940,7 @@
         <p:nvSpPr>
           <p:cNvPr id="2" name="Slide Image Placeholder 1"/>
           <p:cNvSpPr>
-            <a:spLocks noGrp="1" noRot="1" noChangeAspect="1"/>
+            <a:spLocks noChangeAspect="1" noGrp="1" noRot="1"/>
           </p:cNvSpPr>
           <p:nvPr>
             <p:ph type="sldImg"/>
@@ -1955,7 +1955,7 @@
             <a:spLocks noGrp="1"/>
           </p:cNvSpPr>
           <p:nvPr>
-            <p:ph type="body" idx="1"/>
+            <p:ph idx="1" type="body"/>
           </p:nvPr>
         </p:nvSpPr>
         <p:spPr/>
@@ -2026,7 +2026,7 @@
 </file>
 
 <file path=ppt/notesSlides/notesSlide2.xml><?xml version="1.0" encoding="utf-8"?>
-<p:notes xmlns:a="http://schemas.openxmlformats.org/drawingml/2006/main" xmlns:r="http://schemas.openxmlformats.org/officeDocument/2006/relationships" xmlns:p="http://schemas.openxmlformats.org/presentationml/2006/main">
+<p:notes xmlns:a="http://schemas.openxmlformats.org/drawingml/2006/main" xmlns:p="http://schemas.openxmlformats.org/presentationml/2006/main" xmlns:r="http://schemas.openxmlformats.org/officeDocument/2006/relationships">
   <p:cSld>
     <p:spTree>
       <p:nvGrpSpPr>
@@ -2046,7 +2046,7 @@
         <p:nvSpPr>
           <p:cNvPr id="2" name="Slide Image Placeholder 1"/>
           <p:cNvSpPr>
-            <a:spLocks noGrp="1" noRot="1" noChangeAspect="1"/>
+            <a:spLocks noChangeAspect="1" noGrp="1" noRot="1"/>
           </p:cNvSpPr>
           <p:nvPr>
             <p:ph type="sldImg"/>
@@ -2061,7 +2061,7 @@
             <a:spLocks noGrp="1"/>
           </p:cNvSpPr>
           <p:nvPr>
-            <p:ph type="body" idx="1"/>
+            <p:ph idx="1" type="body"/>
           </p:nvPr>
         </p:nvSpPr>
         <p:spPr/>
@@ -2120,7 +2120,7 @@
 </file>
 
 <file path=ppt/notesSlides/notesSlide3.xml><?xml version="1.0" encoding="utf-8"?>
-<p:notes xmlns:a="http://schemas.openxmlformats.org/drawingml/2006/main" xmlns:r="http://schemas.openxmlformats.org/officeDocument/2006/relationships" xmlns:p="http://schemas.openxmlformats.org/presentationml/2006/main">
+<p:notes xmlns:a="http://schemas.openxmlformats.org/drawingml/2006/main" xmlns:p="http://schemas.openxmlformats.org/presentationml/2006/main" xmlns:r="http://schemas.openxmlformats.org/officeDocument/2006/relationships">
   <p:cSld>
     <p:spTree>
       <p:nvGrpSpPr>
@@ -2140,7 +2140,7 @@
         <p:nvSpPr>
           <p:cNvPr id="2" name="Slide Image Placeholder 1"/>
           <p:cNvSpPr>
-            <a:spLocks noGrp="1" noRot="1" noChangeAspect="1"/>
+            <a:spLocks noChangeAspect="1" noGrp="1" noRot="1"/>
           </p:cNvSpPr>
           <p:nvPr>
             <p:ph type="sldImg"/>
@@ -2155,7 +2155,7 @@
             <a:spLocks noGrp="1"/>
           </p:cNvSpPr>
           <p:nvPr>
-            <p:ph type="body" idx="1"/>
+            <p:ph idx="1" type="body"/>
           </p:nvPr>
         </p:nvSpPr>
         <p:spPr/>
@@ -2255,7 +2255,7 @@
 </file>
 
 <file path=ppt/notesSlides/notesSlide4.xml><?xml version="1.0" encoding="utf-8"?>
-<p:notes xmlns:a="http://schemas.openxmlformats.org/drawingml/2006/main" xmlns:r="http://schemas.openxmlformats.org/officeDocument/2006/relationships" xmlns:p="http://schemas.openxmlformats.org/presentationml/2006/main">
+<p:notes xmlns:a="http://schemas.openxmlformats.org/drawingml/2006/main" xmlns:p="http://schemas.openxmlformats.org/presentationml/2006/main" xmlns:r="http://schemas.openxmlformats.org/officeDocument/2006/relationships">
   <p:cSld>
     <p:spTree>
       <p:nvGrpSpPr>
@@ -2275,7 +2275,7 @@
         <p:nvSpPr>
           <p:cNvPr id="2" name="Slide Image Placeholder 1"/>
           <p:cNvSpPr>
-            <a:spLocks noGrp="1" noRot="1" noChangeAspect="1"/>
+            <a:spLocks noChangeAspect="1" noGrp="1" noRot="1"/>
           </p:cNvSpPr>
           <p:nvPr>
             <p:ph type="sldImg"/>
@@ -2290,7 +2290,7 @@
             <a:spLocks noGrp="1"/>
           </p:cNvSpPr>
           <p:nvPr>
-            <p:ph type="body" idx="1"/>
+            <p:ph idx="1" type="body"/>
           </p:nvPr>
         </p:nvSpPr>
         <p:spPr/>
@@ -2349,7 +2349,7 @@
 </file>
 
 <file path=ppt/notesSlides/notesSlide5.xml><?xml version="1.0" encoding="utf-8"?>
-<p:notes xmlns:a="http://schemas.openxmlformats.org/drawingml/2006/main" xmlns:r="http://schemas.openxmlformats.org/officeDocument/2006/relationships" xmlns:p="http://schemas.openxmlformats.org/presentationml/2006/main">
+<p:notes xmlns:a="http://schemas.openxmlformats.org/drawingml/2006/main" xmlns:p="http://schemas.openxmlformats.org/presentationml/2006/main" xmlns:r="http://schemas.openxmlformats.org/officeDocument/2006/relationships">
   <p:cSld>
     <p:spTree>
       <p:nvGrpSpPr>
@@ -2369,7 +2369,7 @@
         <p:nvSpPr>
           <p:cNvPr id="2" name="Slide Image Placeholder 1"/>
           <p:cNvSpPr>
-            <a:spLocks noGrp="1" noRot="1" noChangeAspect="1"/>
+            <a:spLocks noChangeAspect="1" noGrp="1" noRot="1"/>
           </p:cNvSpPr>
           <p:nvPr>
             <p:ph type="sldImg"/>
@@ -2384,7 +2384,7 @@
             <a:spLocks noGrp="1"/>
           </p:cNvSpPr>
           <p:nvPr>
-            <p:ph type="body" idx="1"/>
+            <p:ph idx="1" type="body"/>
           </p:nvPr>
         </p:nvSpPr>
         <p:spPr/>
@@ -2455,7 +2455,7 @@
 </file>
 
 <file path=ppt/notesSlides/notesSlide6.xml><?xml version="1.0" encoding="utf-8"?>
-<p:notes xmlns:a="http://schemas.openxmlformats.org/drawingml/2006/main" xmlns:r="http://schemas.openxmlformats.org/officeDocument/2006/relationships" xmlns:p="http://schemas.openxmlformats.org/presentationml/2006/main">
+<p:notes xmlns:a="http://schemas.openxmlformats.org/drawingml/2006/main" xmlns:p="http://schemas.openxmlformats.org/presentationml/2006/main" xmlns:r="http://schemas.openxmlformats.org/officeDocument/2006/relationships">
   <p:cSld>
     <p:spTree>
       <p:nvGrpSpPr>
@@ -2475,7 +2475,7 @@
         <p:nvSpPr>
           <p:cNvPr id="2" name="Slide Image Placeholder 1"/>
           <p:cNvSpPr>
-            <a:spLocks noGrp="1" noRot="1" noChangeAspect="1"/>
+            <a:spLocks noChangeAspect="1" noGrp="1" noRot="1"/>
           </p:cNvSpPr>
           <p:nvPr>
             <p:ph type="sldImg"/>
@@ -2490,7 +2490,7 @@
             <a:spLocks noGrp="1"/>
           </p:cNvSpPr>
           <p:nvPr>
-            <p:ph type="body" idx="1"/>
+            <p:ph idx="1" type="body"/>
           </p:nvPr>
         </p:nvSpPr>
         <p:spPr/>
@@ -2561,7 +2561,7 @@
 </file>
 
 <file path=ppt/notesSlides/notesSlide7.xml><?xml version="1.0" encoding="utf-8"?>
-<p:notes xmlns:a="http://schemas.openxmlformats.org/drawingml/2006/main" xmlns:r="http://schemas.openxmlformats.org/officeDocument/2006/relationships" xmlns:p="http://schemas.openxmlformats.org/presentationml/2006/main">
+<p:notes xmlns:a="http://schemas.openxmlformats.org/drawingml/2006/main" xmlns:p="http://schemas.openxmlformats.org/presentationml/2006/main" xmlns:r="http://schemas.openxmlformats.org/officeDocument/2006/relationships">
   <p:cSld>
     <p:spTree>
       <p:nvGrpSpPr>
@@ -2581,7 +2581,7 @@
         <p:nvSpPr>
           <p:cNvPr id="2" name="Slide Image Placeholder 1"/>
           <p:cNvSpPr>
-            <a:spLocks noGrp="1" noRot="1" noChangeAspect="1"/>
+            <a:spLocks noChangeAspect="1" noGrp="1" noRot="1"/>
           </p:cNvSpPr>
           <p:nvPr>
             <p:ph type="sldImg"/>
@@ -2596,7 +2596,7 @@
             <a:spLocks noGrp="1"/>
           </p:cNvSpPr>
           <p:nvPr>
-            <p:ph type="body" idx="1"/>
+            <p:ph idx="1" type="body"/>
           </p:nvPr>
         </p:nvSpPr>
         <p:spPr/>
@@ -2667,7 +2667,7 @@
 </file>
 
 <file path=ppt/notesSlides/notesSlide8.xml><?xml version="1.0" encoding="utf-8"?>
-<p:notes xmlns:a="http://schemas.openxmlformats.org/drawingml/2006/main" xmlns:r="http://schemas.openxmlformats.org/officeDocument/2006/relationships" xmlns:p="http://schemas.openxmlformats.org/presentationml/2006/main">
+<p:notes xmlns:a="http://schemas.openxmlformats.org/drawingml/2006/main" xmlns:p="http://schemas.openxmlformats.org/presentationml/2006/main" xmlns:r="http://schemas.openxmlformats.org/officeDocument/2006/relationships">
   <p:cSld>
     <p:spTree>
       <p:nvGrpSpPr>
@@ -2687,7 +2687,7 @@
         <p:nvSpPr>
           <p:cNvPr id="2" name="Slide Image Placeholder 1"/>
           <p:cNvSpPr>
-            <a:spLocks noGrp="1" noRot="1" noChangeAspect="1"/>
+            <a:spLocks noChangeAspect="1" noGrp="1" noRot="1"/>
           </p:cNvSpPr>
           <p:nvPr>
             <p:ph type="sldImg"/>
@@ -2702,7 +2702,7 @@
             <a:spLocks noGrp="1"/>
           </p:cNvSpPr>
           <p:nvPr>
-            <p:ph type="body" idx="1"/>
+            <p:ph idx="1" type="body"/>
           </p:nvPr>
         </p:nvSpPr>
         <p:spPr/>
@@ -2773,7 +2773,7 @@
 </file>
 
 <file path=ppt/notesSlides/notesSlide9.xml><?xml version="1.0" encoding="utf-8"?>
-<p:notes xmlns:a="http://schemas.openxmlformats.org/drawingml/2006/main" xmlns:r="http://schemas.openxmlformats.org/officeDocument/2006/relationships" xmlns:p="http://schemas.openxmlformats.org/presentationml/2006/main">
+<p:notes xmlns:a="http://schemas.openxmlformats.org/drawingml/2006/main" xmlns:p="http://schemas.openxmlformats.org/presentationml/2006/main" xmlns:r="http://schemas.openxmlformats.org/officeDocument/2006/relationships">
   <p:cSld>
     <p:spTree>
       <p:nvGrpSpPr>
@@ -2793,7 +2793,7 @@
         <p:nvSpPr>
           <p:cNvPr id="2" name="Slide Image Placeholder 1"/>
           <p:cNvSpPr>
-            <a:spLocks noGrp="1" noRot="1" noChangeAspect="1"/>
+            <a:spLocks noChangeAspect="1" noGrp="1" noRot="1"/>
           </p:cNvSpPr>
           <p:nvPr>
             <p:ph type="sldImg"/>
@@ -2808,7 +2808,7 @@
             <a:spLocks noGrp="1"/>
           </p:cNvSpPr>
           <p:nvPr>
-            <p:ph type="body" idx="1"/>
+            <p:ph idx="1" type="body"/>
           </p:nvPr>
         </p:nvSpPr>
         <p:spPr/>
@@ -2981,7 +2981,7 @@
 </file>
 
 <file path=ppt/slides/slide1.xml><?xml version="1.0" encoding="utf-8"?>
-<p:sld xmlns:a="http://schemas.openxmlformats.org/drawingml/2006/main" xmlns:r="http://schemas.openxmlformats.org/officeDocument/2006/relationships" xmlns:p="http://schemas.openxmlformats.org/presentationml/2006/main">
+<p:sld xmlns:a="http://schemas.openxmlformats.org/drawingml/2006/main" xmlns:p="http://schemas.openxmlformats.org/presentationml/2006/main" xmlns:r="http://schemas.openxmlformats.org/officeDocument/2006/relationships">
   <p:cSld>
     <p:bg>
       <p:bgPr>
@@ -3362,7 +3362,7 @@
 </file>
 
 <file path=ppt/slides/slide10.xml><?xml version="1.0" encoding="utf-8"?>
-<p:sld xmlns:a="http://schemas.openxmlformats.org/drawingml/2006/main" xmlns:r="http://schemas.openxmlformats.org/officeDocument/2006/relationships" xmlns:p="http://schemas.openxmlformats.org/presentationml/2006/main">
+<p:sld xmlns:a="http://schemas.openxmlformats.org/drawingml/2006/main" xmlns:p="http://schemas.openxmlformats.org/presentationml/2006/main" xmlns:r="http://schemas.openxmlformats.org/officeDocument/2006/relationships">
   <p:cSld>
     <p:bg>
       <p:bgPr>
@@ -3523,6 +3523,22 @@
           </a:p>
         </p:txBody>
       </p:sp>
+      <p:graphicFrame>
+        <p:nvGraphicFramePr>
+          <p:cNvPr id="6" name="Chart 5"/>
+          <p:cNvGraphicFramePr/>
+          <p:nvPr/>
+        </p:nvGraphicFramePr>
+        <p:xfrm>
+          <a:off x="1097280" y="2377440"/>
+          <a:ext cx="2926080" cy="3291840"/>
+        </p:xfrm>
+        <a:graphic>
+          <a:graphicData uri="http://schemas.openxmlformats.org/drawingml/2006/chart">
+            <c:chart xmlns:c="http://schemas.openxmlformats.org/drawingml/2006/chart" xmlns:r="http://schemas.openxmlformats.org/officeDocument/2006/relationships" r:id="rId2"/>
+          </a:graphicData>
+        </a:graphic>
+      </p:graphicFrame>
       <p:sp>
         <p:nvSpPr>
           <p:cNvPr id="7" name="roundRect 6"/>
@@ -3594,6 +3610,22 @@
           </a:p>
         </p:txBody>
       </p:sp>
+      <p:graphicFrame>
+        <p:nvGraphicFramePr>
+          <p:cNvPr id="9" name="Chart 8"/>
+          <p:cNvGraphicFramePr/>
+          <p:nvPr/>
+        </p:nvGraphicFramePr>
+        <p:xfrm>
+          <a:off x="4626864" y="2377440"/>
+          <a:ext cx="2926080" cy="3291840"/>
+        </p:xfrm>
+        <a:graphic>
+          <a:graphicData uri="http://schemas.openxmlformats.org/drawingml/2006/chart">
+            <c:chart xmlns:c="http://schemas.openxmlformats.org/drawingml/2006/chart" xmlns:r="http://schemas.openxmlformats.org/officeDocument/2006/relationships" r:id="rId3"/>
+          </a:graphicData>
+        </a:graphic>
+      </p:graphicFrame>
       <p:sp>
         <p:nvSpPr>
           <p:cNvPr id="10" name="roundRect 9"/>
@@ -3665,71 +3697,6 @@
           </a:p>
         </p:txBody>
       </p:sp>
-      <p:sp>
-        <p:nvSpPr>
-          <p:cNvPr id="13" name="Text Box 12"/>
-          <p:cNvSpPr/>
-          <p:nvPr/>
-        </p:nvSpPr>
-        <p:spPr>
-          <a:xfrm>
-            <a:off x="731520" y="6510528"/>
-            <a:ext cx="10725912" cy="228600"/>
-          </a:xfrm>
-          <a:prstGeom prst="rect">
-            <a:avLst/>
-          </a:prstGeom>
-        </p:spPr>
-        <p:txBody>
-          <a:bodyPr anchor="t"/>
-          <a:lstStyle/>
-          <a:p>
-            <a:pPr algn="ctr"/>
-            <a:r>
-              <a:rPr i="1" sz="800">
-                <a:solidFill>
-                  <a:srgbClr val="94A3B8"/>
-                </a:solidFill>
-                <a:latin typeface="+mn-lt"/>
-                <a:cs typeface="+mn-lt"/>
-              </a:rPr>
-              <a:t>* Disclaimer: All benchmark metrics, performance figures, and simulated architectures in this deck are synthetic demonstration values generated solely to showcase the authoring, formatting, and rendering capabilities of @hokkyss/pptx.</a:t>
-            </a:r>
-          </a:p>
-        </p:txBody>
-      </p:sp>
-      <p:graphicFrame>
-        <p:nvGraphicFramePr>
-          <p:cNvPr id="6" name="Chart 5"/>
-          <p:cNvGraphicFramePr/>
-          <p:nvPr/>
-        </p:nvGraphicFramePr>
-        <p:xfrm>
-          <a:off x="1097280" y="2377440"/>
-          <a:ext cx="2926080" cy="3291840"/>
-        </p:xfrm>
-        <a:graphic>
-          <a:graphicData uri="http://schemas.openxmlformats.org/drawingml/2006/chart">
-            <c:chart xmlns:c="http://schemas.openxmlformats.org/drawingml/2006/chart" xmlns:r="http://schemas.openxmlformats.org/officeDocument/2006/relationships" r:id="rId2"/>
-          </a:graphicData>
-        </a:graphic>
-      </p:graphicFrame>
-      <p:graphicFrame>
-        <p:nvGraphicFramePr>
-          <p:cNvPr id="9" name="Chart 8"/>
-          <p:cNvGraphicFramePr/>
-          <p:nvPr/>
-        </p:nvGraphicFramePr>
-        <p:xfrm>
-          <a:off x="4626864" y="2377440"/>
-          <a:ext cx="2926080" cy="3291840"/>
-        </p:xfrm>
-        <a:graphic>
-          <a:graphicData uri="http://schemas.openxmlformats.org/drawingml/2006/chart">
-            <c:chart xmlns:c="http://schemas.openxmlformats.org/drawingml/2006/chart" xmlns:r="http://schemas.openxmlformats.org/officeDocument/2006/relationships" r:id="rId3"/>
-          </a:graphicData>
-        </a:graphic>
-      </p:graphicFrame>
       <p:graphicFrame>
         <p:nvGraphicFramePr>
           <p:cNvPr id="12" name="Chart 11"/>
@@ -3746,6 +3713,39 @@
           </a:graphicData>
         </a:graphic>
       </p:graphicFrame>
+      <p:sp>
+        <p:nvSpPr>
+          <p:cNvPr id="13" name="Text Box 12"/>
+          <p:cNvSpPr/>
+          <p:nvPr/>
+        </p:nvSpPr>
+        <p:spPr>
+          <a:xfrm>
+            <a:off x="731520" y="6510528"/>
+            <a:ext cx="10725912" cy="228600"/>
+          </a:xfrm>
+          <a:prstGeom prst="rect">
+            <a:avLst/>
+          </a:prstGeom>
+        </p:spPr>
+        <p:txBody>
+          <a:bodyPr anchor="t"/>
+          <a:lstStyle/>
+          <a:p>
+            <a:pPr algn="ctr"/>
+            <a:r>
+              <a:rPr i="1" sz="800">
+                <a:solidFill>
+                  <a:srgbClr val="94A3B8"/>
+                </a:solidFill>
+                <a:latin typeface="+mn-lt"/>
+                <a:cs typeface="+mn-lt"/>
+              </a:rPr>
+              <a:t>* Disclaimer: All benchmark metrics, performance figures, and simulated architectures in this deck are synthetic demonstration values generated solely to showcase the authoring, formatting, and rendering capabilities of @hokkyss/pptx.</a:t>
+            </a:r>
+          </a:p>
+        </p:txBody>
+      </p:sp>
     </p:spTree>
   </p:cSld>
   <p:clrMapOvr>
@@ -3758,7 +3758,7 @@
 </file>
 
 <file path=ppt/slides/slide11.xml><?xml version="1.0" encoding="utf-8"?>
-<p:sld xmlns:a="http://schemas.openxmlformats.org/drawingml/2006/main" xmlns:r="http://schemas.openxmlformats.org/officeDocument/2006/relationships" xmlns:p="http://schemas.openxmlformats.org/presentationml/2006/main">
+<p:sld xmlns:a="http://schemas.openxmlformats.org/drawingml/2006/main" xmlns:p="http://schemas.openxmlformats.org/presentationml/2006/main" xmlns:r="http://schemas.openxmlformats.org/officeDocument/2006/relationships">
   <p:cSld>
     <p:bg>
       <p:bgPr>
@@ -3919,6 +3919,22 @@
           </a:p>
         </p:txBody>
       </p:sp>
+      <p:graphicFrame>
+        <p:nvGraphicFramePr>
+          <p:cNvPr id="6" name="Chart 5"/>
+          <p:cNvGraphicFramePr/>
+          <p:nvPr/>
+        </p:nvGraphicFramePr>
+        <p:xfrm>
+          <a:off x="1097280" y="2377440"/>
+          <a:ext cx="2926080" cy="3291840"/>
+        </p:xfrm>
+        <a:graphic>
+          <a:graphicData uri="http://schemas.openxmlformats.org/drawingml/2006/chart">
+            <c:chart xmlns:c="http://schemas.openxmlformats.org/drawingml/2006/chart" xmlns:r="http://schemas.openxmlformats.org/officeDocument/2006/relationships" r:id="rId2"/>
+          </a:graphicData>
+        </a:graphic>
+      </p:graphicFrame>
       <p:sp>
         <p:nvSpPr>
           <p:cNvPr id="7" name="roundRect 6"/>
@@ -3990,6 +4006,22 @@
           </a:p>
         </p:txBody>
       </p:sp>
+      <p:graphicFrame>
+        <p:nvGraphicFramePr>
+          <p:cNvPr id="9" name="Chart 8"/>
+          <p:cNvGraphicFramePr/>
+          <p:nvPr/>
+        </p:nvGraphicFramePr>
+        <p:xfrm>
+          <a:off x="4626864" y="2377440"/>
+          <a:ext cx="2926080" cy="3291840"/>
+        </p:xfrm>
+        <a:graphic>
+          <a:graphicData uri="http://schemas.openxmlformats.org/drawingml/2006/chart">
+            <c:chart xmlns:c="http://schemas.openxmlformats.org/drawingml/2006/chart" xmlns:r="http://schemas.openxmlformats.org/officeDocument/2006/relationships" r:id="rId3"/>
+          </a:graphicData>
+        </a:graphic>
+      </p:graphicFrame>
       <p:sp>
         <p:nvSpPr>
           <p:cNvPr id="10" name="roundRect 9"/>
@@ -4061,71 +4093,6 @@
           </a:p>
         </p:txBody>
       </p:sp>
-      <p:sp>
-        <p:nvSpPr>
-          <p:cNvPr id="13" name="Text Box 12"/>
-          <p:cNvSpPr/>
-          <p:nvPr/>
-        </p:nvSpPr>
-        <p:spPr>
-          <a:xfrm>
-            <a:off x="731520" y="6510528"/>
-            <a:ext cx="10725912" cy="228600"/>
-          </a:xfrm>
-          <a:prstGeom prst="rect">
-            <a:avLst/>
-          </a:prstGeom>
-        </p:spPr>
-        <p:txBody>
-          <a:bodyPr anchor="t"/>
-          <a:lstStyle/>
-          <a:p>
-            <a:pPr algn="ctr"/>
-            <a:r>
-              <a:rPr i="1" sz="800">
-                <a:solidFill>
-                  <a:srgbClr val="64748B"/>
-                </a:solidFill>
-                <a:latin typeface="+mn-lt"/>
-                <a:cs typeface="+mn-lt"/>
-              </a:rPr>
-              <a:t>* Disclaimer: All benchmark metrics, performance figures, and simulated architectures in this deck are synthetic demonstration values generated solely to showcase the authoring, formatting, and rendering capabilities of @hokkyss/pptx.</a:t>
-            </a:r>
-          </a:p>
-        </p:txBody>
-      </p:sp>
-      <p:graphicFrame>
-        <p:nvGraphicFramePr>
-          <p:cNvPr id="6" name="Chart 5"/>
-          <p:cNvGraphicFramePr/>
-          <p:nvPr/>
-        </p:nvGraphicFramePr>
-        <p:xfrm>
-          <a:off x="1097280" y="2377440"/>
-          <a:ext cx="2926080" cy="3291840"/>
-        </p:xfrm>
-        <a:graphic>
-          <a:graphicData uri="http://schemas.openxmlformats.org/drawingml/2006/chart">
-            <c:chart xmlns:c="http://schemas.openxmlformats.org/drawingml/2006/chart" xmlns:r="http://schemas.openxmlformats.org/officeDocument/2006/relationships" r:id="rId2"/>
-          </a:graphicData>
-        </a:graphic>
-      </p:graphicFrame>
-      <p:graphicFrame>
-        <p:nvGraphicFramePr>
-          <p:cNvPr id="9" name="Chart 8"/>
-          <p:cNvGraphicFramePr/>
-          <p:nvPr/>
-        </p:nvGraphicFramePr>
-        <p:xfrm>
-          <a:off x="4626864" y="2377440"/>
-          <a:ext cx="2926080" cy="3291840"/>
-        </p:xfrm>
-        <a:graphic>
-          <a:graphicData uri="http://schemas.openxmlformats.org/drawingml/2006/chart">
-            <c:chart xmlns:c="http://schemas.openxmlformats.org/drawingml/2006/chart" xmlns:r="http://schemas.openxmlformats.org/officeDocument/2006/relationships" r:id="rId3"/>
-          </a:graphicData>
-        </a:graphic>
-      </p:graphicFrame>
       <p:graphicFrame>
         <p:nvGraphicFramePr>
           <p:cNvPr id="12" name="Chart 11"/>
@@ -4142,6 +4109,39 @@
           </a:graphicData>
         </a:graphic>
       </p:graphicFrame>
+      <p:sp>
+        <p:nvSpPr>
+          <p:cNvPr id="13" name="Text Box 12"/>
+          <p:cNvSpPr/>
+          <p:nvPr/>
+        </p:nvSpPr>
+        <p:spPr>
+          <a:xfrm>
+            <a:off x="731520" y="6510528"/>
+            <a:ext cx="10725912" cy="228600"/>
+          </a:xfrm>
+          <a:prstGeom prst="rect">
+            <a:avLst/>
+          </a:prstGeom>
+        </p:spPr>
+        <p:txBody>
+          <a:bodyPr anchor="t"/>
+          <a:lstStyle/>
+          <a:p>
+            <a:pPr algn="ctr"/>
+            <a:r>
+              <a:rPr i="1" sz="800">
+                <a:solidFill>
+                  <a:srgbClr val="64748B"/>
+                </a:solidFill>
+                <a:latin typeface="+mn-lt"/>
+                <a:cs typeface="+mn-lt"/>
+              </a:rPr>
+              <a:t>* Disclaimer: All benchmark metrics, performance figures, and simulated architectures in this deck are synthetic demonstration values generated solely to showcase the authoring, formatting, and rendering capabilities of @hokkyss/pptx.</a:t>
+            </a:r>
+          </a:p>
+        </p:txBody>
+      </p:sp>
     </p:spTree>
   </p:cSld>
   <p:clrMapOvr>
@@ -4154,7 +4154,7 @@
 </file>
 
 <file path=ppt/slides/slide12.xml><?xml version="1.0" encoding="utf-8"?>
-<p:sld xmlns:a="http://schemas.openxmlformats.org/drawingml/2006/main" xmlns:r="http://schemas.openxmlformats.org/officeDocument/2006/relationships" xmlns:p="http://schemas.openxmlformats.org/presentationml/2006/main">
+<p:sld xmlns:a="http://schemas.openxmlformats.org/drawingml/2006/main" xmlns:p="http://schemas.openxmlformats.org/presentationml/2006/main" xmlns:r="http://schemas.openxmlformats.org/officeDocument/2006/relationships">
   <p:cSld>
     <p:bg>
       <p:bgPr>
@@ -5048,7 +5048,7 @@
 </file>
 
 <file path=ppt/slides/slide13.xml><?xml version="1.0" encoding="utf-8"?>
-<p:sld xmlns:a="http://schemas.openxmlformats.org/drawingml/2006/main" xmlns:r="http://schemas.openxmlformats.org/officeDocument/2006/relationships" xmlns:p="http://schemas.openxmlformats.org/presentationml/2006/main">
+<p:sld xmlns:a="http://schemas.openxmlformats.org/drawingml/2006/main" xmlns:p="http://schemas.openxmlformats.org/presentationml/2006/main" xmlns:r="http://schemas.openxmlformats.org/officeDocument/2006/relationships">
   <p:cSld>
     <p:bg>
       <p:bgPr>
@@ -5915,7 +5915,7 @@
 </file>
 
 <file path=ppt/slides/slide14.xml><?xml version="1.0" encoding="utf-8"?>
-<p:sld xmlns:a="http://schemas.openxmlformats.org/drawingml/2006/main" xmlns:r="http://schemas.openxmlformats.org/officeDocument/2006/relationships" xmlns:p="http://schemas.openxmlformats.org/presentationml/2006/main">
+<p:sld xmlns:a="http://schemas.openxmlformats.org/drawingml/2006/main" xmlns:p="http://schemas.openxmlformats.org/presentationml/2006/main" xmlns:r="http://schemas.openxmlformats.org/officeDocument/2006/relationships">
   <p:cSld>
     <p:bg>
       <p:bgPr>
@@ -6072,160 +6072,6 @@
                 <a:cs typeface="+mn-lt"/>
               </a:rPr>
               <a:t>⚡ Throughput &amp; Latency Benchmarks (Vitest)</a:t>
-            </a:r>
-          </a:p>
-        </p:txBody>
-      </p:sp>
-      <p:sp>
-        <p:nvSpPr>
-          <p:cNvPr id="7" name="roundRect 6"/>
-          <p:cNvSpPr/>
-          <p:nvPr/>
-        </p:nvSpPr>
-        <p:spPr>
-          <a:xfrm>
-            <a:off x="6217920" y="1828800"/>
-            <a:ext cx="5212080" cy="4480560"/>
-          </a:xfrm>
-          <a:prstGeom prst="roundRect">
-            <a:avLst/>
-          </a:prstGeom>
-          <a:solidFill>
-            <a:srgbClr val="1E293B"/>
-          </a:solidFill>
-          <a:ln w="13716">
-            <a:solidFill>
-              <a:srgbClr val="334155"/>
-            </a:solidFill>
-          </a:ln>
-          <a:effectLst>
-            <a:outerShdw blurRad="109728" dist="38100" dir="5400000">
-              <a:srgbClr val="000000">
-                <a:alpha val="30000"/>
-              </a:srgbClr>
-            </a:outerShdw>
-          </a:effectLst>
-        </p:spPr>
-        <p:txBody>
-          <a:bodyPr/>
-          <a:lstStyle/>
-          <a:p>
-            <a:endParaRPr/>
-          </a:p>
-        </p:txBody>
-      </p:sp>
-      <p:sp>
-        <p:nvSpPr>
-          <p:cNvPr id="8" name="Text Box 7"/>
-          <p:cNvSpPr/>
-          <p:nvPr/>
-        </p:nvSpPr>
-        <p:spPr>
-          <a:xfrm>
-            <a:off x="6400800" y="2011680"/>
-            <a:ext cx="4846320" cy="320040"/>
-          </a:xfrm>
-          <a:prstGeom prst="rect">
-            <a:avLst/>
-          </a:prstGeom>
-        </p:spPr>
-        <p:txBody>
-          <a:bodyPr anchor="t"/>
-          <a:lstStyle/>
-          <a:p>
-            <a:pPr algn="l"/>
-            <a:r>
-              <a:rPr b="1" sz="1300">
-                <a:solidFill>
-                  <a:srgbClr val="FFFFFF"/>
-                </a:solidFill>
-                <a:latin typeface="+mn-lt"/>
-                <a:cs typeface="+mn-lt"/>
-              </a:rPr>
-              <a:t>📦 Monorepo Gzip &amp; Brotli Footprint (Bundlephobia-Aligned)</a:t>
-            </a:r>
-          </a:p>
-        </p:txBody>
-      </p:sp>
-      <p:sp>
-        <p:nvSpPr>
-          <p:cNvPr id="10" name="roundRect 9">
-            <a:hlinkClick r:id="rId3" tooltip="Return to Hyperlinks Hub (Slide 12)" action="ppaction://hlinksldjump"/>
-          </p:cNvPr>
-          <p:cNvSpPr/>
-          <p:nvPr/>
-        </p:nvSpPr>
-        <p:spPr>
-          <a:xfrm>
-            <a:off x="9144000" y="731520"/>
-            <a:ext cx="2194560" cy="411480"/>
-          </a:xfrm>
-          <a:prstGeom prst="roundRect">
-            <a:avLst/>
-          </a:prstGeom>
-          <a:solidFill>
-            <a:srgbClr val="0284C7"/>
-          </a:solidFill>
-          <a:ln w="13716">
-            <a:solidFill>
-              <a:srgbClr val="38BDF8"/>
-            </a:solidFill>
-          </a:ln>
-          <a:effectLst>
-            <a:outerShdw blurRad="137160" dist="27432" dir="5400000">
-              <a:srgbClr val="0284C7">
-                <a:alpha val="30000"/>
-              </a:srgbClr>
-            </a:outerShdw>
-          </a:effectLst>
-        </p:spPr>
-        <p:txBody>
-          <a:bodyPr anchor="t"/>
-          <a:lstStyle/>
-          <a:p>
-            <a:pPr algn="ctr"/>
-            <a:r>
-              <a:rPr b="1" sz="1000">
-                <a:solidFill>
-                  <a:srgbClr val="FFFFFF"/>
-                </a:solidFill>
-                <a:latin typeface="+mn-lt"/>
-                <a:cs typeface="+mn-lt"/>
-              </a:rPr>
-              <a:t>⬅ Back to Nav Hub</a:t>
-            </a:r>
-          </a:p>
-        </p:txBody>
-      </p:sp>
-      <p:sp>
-        <p:nvSpPr>
-          <p:cNvPr id="11" name="Text Box 10"/>
-          <p:cNvSpPr/>
-          <p:nvPr/>
-        </p:nvSpPr>
-        <p:spPr>
-          <a:xfrm>
-            <a:off x="731520" y="6510528"/>
-            <a:ext cx="10725912" cy="228600"/>
-          </a:xfrm>
-          <a:prstGeom prst="rect">
-            <a:avLst/>
-          </a:prstGeom>
-        </p:spPr>
-        <p:txBody>
-          <a:bodyPr anchor="t"/>
-          <a:lstStyle/>
-          <a:p>
-            <a:pPr algn="ctr"/>
-            <a:r>
-              <a:rPr i="1" sz="800">
-                <a:solidFill>
-                  <a:srgbClr val="64748B"/>
-                </a:solidFill>
-                <a:latin typeface="+mn-lt"/>
-                <a:cs typeface="+mn-lt"/>
-              </a:rPr>
-              <a:t>* Disclaimer: All benchmark metrics, performance figures, and simulated architectures in this deck are synthetic demonstration values generated solely to showcase the authoring, formatting, and rendering capabilities of @hokkyss/pptx.</a:t>
             </a:r>
           </a:p>
         </p:txBody>
@@ -6271,7 +6117,7 @@
                       </a:r>
                     </a:p>
                   </a:txBody>
-                  <a:tcPr>
+                  <a:tcPr anchor="ctr">
                     <a:solidFill>
                       <a:srgbClr val="0284C7"/>
                     </a:solidFill>
@@ -6295,7 +6141,7 @@
                       </a:r>
                     </a:p>
                   </a:txBody>
-                  <a:tcPr>
+                  <a:tcPr anchor="ctr">
                     <a:solidFill>
                       <a:srgbClr val="0284C7"/>
                     </a:solidFill>
@@ -6319,7 +6165,7 @@
                       </a:r>
                     </a:p>
                   </a:txBody>
-                  <a:tcPr>
+                  <a:tcPr anchor="ctr">
                     <a:solidFill>
                       <a:srgbClr val="0284C7"/>
                     </a:solidFill>
@@ -6343,7 +6189,7 @@
                       </a:r>
                     </a:p>
                   </a:txBody>
-                  <a:tcPr>
+                  <a:tcPr anchor="ctr">
                     <a:solidFill>
                       <a:srgbClr val="0284C7"/>
                     </a:solidFill>
@@ -6369,7 +6215,7 @@
                       </a:r>
                     </a:p>
                   </a:txBody>
-                  <a:tcPr>
+                  <a:tcPr anchor="ctr">
                     <a:solidFill>
                       <a:srgbClr val="1E293B"/>
                     </a:solidFill>
@@ -6393,7 +6239,7 @@
                       </a:r>
                     </a:p>
                   </a:txBody>
-                  <a:tcPr>
+                  <a:tcPr anchor="ctr">
                     <a:solidFill>
                       <a:srgbClr val="1E293B"/>
                     </a:solidFill>
@@ -6417,7 +6263,7 @@
                       </a:r>
                     </a:p>
                   </a:txBody>
-                  <a:tcPr>
+                  <a:tcPr anchor="ctr">
                     <a:solidFill>
                       <a:srgbClr val="1E293B"/>
                     </a:solidFill>
@@ -6441,7 +6287,7 @@
                       </a:r>
                     </a:p>
                   </a:txBody>
-                  <a:tcPr>
+                  <a:tcPr anchor="ctr">
                     <a:solidFill>
                       <a:srgbClr val="1E293B"/>
                     </a:solidFill>
@@ -6467,7 +6313,7 @@
                       </a:r>
                     </a:p>
                   </a:txBody>
-                  <a:tcPr>
+                  <a:tcPr anchor="ctr">
                     <a:solidFill>
                       <a:srgbClr val="0F172A"/>
                     </a:solidFill>
@@ -6491,7 +6337,7 @@
                       </a:r>
                     </a:p>
                   </a:txBody>
-                  <a:tcPr>
+                  <a:tcPr anchor="ctr">
                     <a:solidFill>
                       <a:srgbClr val="0F172A"/>
                     </a:solidFill>
@@ -6515,7 +6361,7 @@
                       </a:r>
                     </a:p>
                   </a:txBody>
-                  <a:tcPr>
+                  <a:tcPr anchor="ctr">
                     <a:solidFill>
                       <a:srgbClr val="0F172A"/>
                     </a:solidFill>
@@ -6539,7 +6385,7 @@
                       </a:r>
                     </a:p>
                   </a:txBody>
-                  <a:tcPr>
+                  <a:tcPr anchor="ctr">
                     <a:solidFill>
                       <a:srgbClr val="0F172A"/>
                     </a:solidFill>
@@ -6565,7 +6411,7 @@
                       </a:r>
                     </a:p>
                   </a:txBody>
-                  <a:tcPr>
+                  <a:tcPr anchor="ctr">
                     <a:solidFill>
                       <a:srgbClr val="1E293B"/>
                     </a:solidFill>
@@ -6589,7 +6435,7 @@
                       </a:r>
                     </a:p>
                   </a:txBody>
-                  <a:tcPr>
+                  <a:tcPr anchor="ctr">
                     <a:solidFill>
                       <a:srgbClr val="1E293B"/>
                     </a:solidFill>
@@ -6613,7 +6459,7 @@
                       </a:r>
                     </a:p>
                   </a:txBody>
-                  <a:tcPr>
+                  <a:tcPr anchor="ctr">
                     <a:solidFill>
                       <a:srgbClr val="1E293B"/>
                     </a:solidFill>
@@ -6637,7 +6483,7 @@
                       </a:r>
                     </a:p>
                   </a:txBody>
-                  <a:tcPr>
+                  <a:tcPr anchor="ctr">
                     <a:solidFill>
                       <a:srgbClr val="1E293B"/>
                     </a:solidFill>
@@ -6663,7 +6509,7 @@
                       </a:r>
                     </a:p>
                   </a:txBody>
-                  <a:tcPr>
+                  <a:tcPr anchor="ctr">
                     <a:solidFill>
                       <a:srgbClr val="0F172A"/>
                     </a:solidFill>
@@ -6687,7 +6533,7 @@
                       </a:r>
                     </a:p>
                   </a:txBody>
-                  <a:tcPr>
+                  <a:tcPr anchor="ctr">
                     <a:solidFill>
                       <a:srgbClr val="0F172A"/>
                     </a:solidFill>
@@ -6711,7 +6557,7 @@
                       </a:r>
                     </a:p>
                   </a:txBody>
-                  <a:tcPr>
+                  <a:tcPr anchor="ctr">
                     <a:solidFill>
                       <a:srgbClr val="0F172A"/>
                     </a:solidFill>
@@ -6735,7 +6581,7 @@
                       </a:r>
                     </a:p>
                   </a:txBody>
-                  <a:tcPr>
+                  <a:tcPr anchor="ctr">
                     <a:solidFill>
                       <a:srgbClr val="0F172A"/>
                     </a:solidFill>
@@ -6761,7 +6607,7 @@
                       </a:r>
                     </a:p>
                   </a:txBody>
-                  <a:tcPr>
+                  <a:tcPr anchor="ctr">
                     <a:solidFill>
                       <a:srgbClr val="1E293B"/>
                     </a:solidFill>
@@ -6785,7 +6631,7 @@
                       </a:r>
                     </a:p>
                   </a:txBody>
-                  <a:tcPr>
+                  <a:tcPr anchor="ctr">
                     <a:solidFill>
                       <a:srgbClr val="1E293B"/>
                     </a:solidFill>
@@ -6809,7 +6655,7 @@
                       </a:r>
                     </a:p>
                   </a:txBody>
-                  <a:tcPr>
+                  <a:tcPr anchor="ctr">
                     <a:solidFill>
                       <a:srgbClr val="1E293B"/>
                     </a:solidFill>
@@ -6833,7 +6679,7 @@
                       </a:r>
                     </a:p>
                   </a:txBody>
-                  <a:tcPr>
+                  <a:tcPr anchor="ctr">
                     <a:solidFill>
                       <a:srgbClr val="1E293B"/>
                     </a:solidFill>
@@ -6859,7 +6705,7 @@
                       </a:r>
                     </a:p>
                   </a:txBody>
-                  <a:tcPr>
+                  <a:tcPr anchor="ctr">
                     <a:solidFill>
                       <a:srgbClr val="0F172A"/>
                     </a:solidFill>
@@ -6883,7 +6729,7 @@
                       </a:r>
                     </a:p>
                   </a:txBody>
-                  <a:tcPr>
+                  <a:tcPr anchor="ctr">
                     <a:solidFill>
                       <a:srgbClr val="0F172A"/>
                     </a:solidFill>
@@ -6907,7 +6753,7 @@
                       </a:r>
                     </a:p>
                   </a:txBody>
-                  <a:tcPr>
+                  <a:tcPr anchor="ctr">
                     <a:solidFill>
                       <a:srgbClr val="0F172A"/>
                     </a:solidFill>
@@ -6931,7 +6777,7 @@
                       </a:r>
                     </a:p>
                   </a:txBody>
-                  <a:tcPr>
+                  <a:tcPr anchor="ctr">
                     <a:solidFill>
                       <a:srgbClr val="0F172A"/>
                     </a:solidFill>
@@ -6942,6 +6788,77 @@
           </a:graphicData>
         </a:graphic>
       </p:graphicFrame>
+      <p:sp>
+        <p:nvSpPr>
+          <p:cNvPr id="7" name="roundRect 6"/>
+          <p:cNvSpPr/>
+          <p:nvPr/>
+        </p:nvSpPr>
+        <p:spPr>
+          <a:xfrm>
+            <a:off x="6217920" y="1828800"/>
+            <a:ext cx="5212080" cy="4480560"/>
+          </a:xfrm>
+          <a:prstGeom prst="roundRect">
+            <a:avLst/>
+          </a:prstGeom>
+          <a:solidFill>
+            <a:srgbClr val="1E293B"/>
+          </a:solidFill>
+          <a:ln w="13716">
+            <a:solidFill>
+              <a:srgbClr val="334155"/>
+            </a:solidFill>
+          </a:ln>
+          <a:effectLst>
+            <a:outerShdw blurRad="109728" dist="38100" dir="5400000">
+              <a:srgbClr val="000000">
+                <a:alpha val="30000"/>
+              </a:srgbClr>
+            </a:outerShdw>
+          </a:effectLst>
+        </p:spPr>
+        <p:txBody>
+          <a:bodyPr/>
+          <a:lstStyle/>
+          <a:p>
+            <a:endParaRPr/>
+          </a:p>
+        </p:txBody>
+      </p:sp>
+      <p:sp>
+        <p:nvSpPr>
+          <p:cNvPr id="8" name="Text Box 7"/>
+          <p:cNvSpPr/>
+          <p:nvPr/>
+        </p:nvSpPr>
+        <p:spPr>
+          <a:xfrm>
+            <a:off x="6400800" y="2011680"/>
+            <a:ext cx="4846320" cy="320040"/>
+          </a:xfrm>
+          <a:prstGeom prst="rect">
+            <a:avLst/>
+          </a:prstGeom>
+        </p:spPr>
+        <p:txBody>
+          <a:bodyPr anchor="t"/>
+          <a:lstStyle/>
+          <a:p>
+            <a:pPr algn="l"/>
+            <a:r>
+              <a:rPr b="1" sz="1300">
+                <a:solidFill>
+                  <a:srgbClr val="FFFFFF"/>
+                </a:solidFill>
+                <a:latin typeface="+mn-lt"/>
+                <a:cs typeface="+mn-lt"/>
+              </a:rPr>
+              <a:t>📦 Monorepo Gzip &amp; Brotli Footprint (Bundlephobia-Aligned)</a:t>
+            </a:r>
+          </a:p>
+        </p:txBody>
+      </p:sp>
       <p:graphicFrame>
         <p:nvGraphicFramePr>
           <p:cNvPr id="9" name="Chart 8"/>
@@ -6958,6 +6875,89 @@
           </a:graphicData>
         </a:graphic>
       </p:graphicFrame>
+      <p:sp>
+        <p:nvSpPr>
+          <p:cNvPr id="10" name="roundRect 9">
+            <a:hlinkClick r:id="rId3" tooltip="Return to Hyperlinks Hub (Slide 12)" action="ppaction://hlinksldjump"/>
+          </p:cNvPr>
+          <p:cNvSpPr/>
+          <p:nvPr/>
+        </p:nvSpPr>
+        <p:spPr>
+          <a:xfrm>
+            <a:off x="9144000" y="731520"/>
+            <a:ext cx="2194560" cy="411480"/>
+          </a:xfrm>
+          <a:prstGeom prst="roundRect">
+            <a:avLst/>
+          </a:prstGeom>
+          <a:solidFill>
+            <a:srgbClr val="0284C7"/>
+          </a:solidFill>
+          <a:ln w="13716">
+            <a:solidFill>
+              <a:srgbClr val="38BDF8"/>
+            </a:solidFill>
+          </a:ln>
+          <a:effectLst>
+            <a:outerShdw blurRad="137160" dist="27432" dir="5400000">
+              <a:srgbClr val="0284C7">
+                <a:alpha val="30000"/>
+              </a:srgbClr>
+            </a:outerShdw>
+          </a:effectLst>
+        </p:spPr>
+        <p:txBody>
+          <a:bodyPr anchor="t"/>
+          <a:lstStyle/>
+          <a:p>
+            <a:pPr algn="ctr"/>
+            <a:r>
+              <a:rPr b="1" sz="1000">
+                <a:solidFill>
+                  <a:srgbClr val="FFFFFF"/>
+                </a:solidFill>
+                <a:latin typeface="+mn-lt"/>
+                <a:cs typeface="+mn-lt"/>
+              </a:rPr>
+              <a:t>⬅ Back to Nav Hub</a:t>
+            </a:r>
+          </a:p>
+        </p:txBody>
+      </p:sp>
+      <p:sp>
+        <p:nvSpPr>
+          <p:cNvPr id="11" name="Text Box 10"/>
+          <p:cNvSpPr/>
+          <p:nvPr/>
+        </p:nvSpPr>
+        <p:spPr>
+          <a:xfrm>
+            <a:off x="731520" y="6510528"/>
+            <a:ext cx="10725912" cy="228600"/>
+          </a:xfrm>
+          <a:prstGeom prst="rect">
+            <a:avLst/>
+          </a:prstGeom>
+        </p:spPr>
+        <p:txBody>
+          <a:bodyPr anchor="t"/>
+          <a:lstStyle/>
+          <a:p>
+            <a:pPr algn="ctr"/>
+            <a:r>
+              <a:rPr i="1" sz="800">
+                <a:solidFill>
+                  <a:srgbClr val="64748B"/>
+                </a:solidFill>
+                <a:latin typeface="+mn-lt"/>
+                <a:cs typeface="+mn-lt"/>
+              </a:rPr>
+              <a:t>* Disclaimer: All benchmark metrics, performance figures, and simulated architectures in this deck are synthetic demonstration values generated solely to showcase the authoring, formatting, and rendering capabilities of @hokkyss/pptx.</a:t>
+            </a:r>
+          </a:p>
+        </p:txBody>
+      </p:sp>
     </p:spTree>
   </p:cSld>
   <p:clrMapOvr>
@@ -6970,7 +6970,7 @@
 </file>
 
 <file path=ppt/slides/slide2.xml><?xml version="1.0" encoding="utf-8"?>
-<p:sld xmlns:a="http://schemas.openxmlformats.org/drawingml/2006/main" xmlns:r="http://schemas.openxmlformats.org/officeDocument/2006/relationships" xmlns:p="http://schemas.openxmlformats.org/presentationml/2006/main">
+<p:sld xmlns:a="http://schemas.openxmlformats.org/drawingml/2006/main" xmlns:p="http://schemas.openxmlformats.org/presentationml/2006/main" xmlns:r="http://schemas.openxmlformats.org/officeDocument/2006/relationships">
   <p:cSld>
     <p:bg>
       <p:bgPr>
@@ -7502,7 +7502,7 @@
 </file>
 
 <file path=ppt/slides/slide3.xml><?xml version="1.0" encoding="utf-8"?>
-<p:sld xmlns:a="http://schemas.openxmlformats.org/drawingml/2006/main" xmlns:r="http://schemas.openxmlformats.org/officeDocument/2006/relationships" xmlns:p="http://schemas.openxmlformats.org/presentationml/2006/main">
+<p:sld xmlns:a="http://schemas.openxmlformats.org/drawingml/2006/main" xmlns:p="http://schemas.openxmlformats.org/presentationml/2006/main" xmlns:r="http://schemas.openxmlformats.org/officeDocument/2006/relationships">
   <p:cSld>
     <p:bg>
       <p:bgPr>
@@ -7588,39 +7588,6 @@
                 <a:cs typeface="+mn-lt"/>
               </a:rPr>
               <a:t>100-slide roundtrip parse &amp; compilation benchmarks across modern JavaScript engines</a:t>
-            </a:r>
-          </a:p>
-        </p:txBody>
-      </p:sp>
-      <p:sp>
-        <p:nvSpPr>
-          <p:cNvPr id="5" name="Text Box 4"/>
-          <p:cNvSpPr/>
-          <p:nvPr/>
-        </p:nvSpPr>
-        <p:spPr>
-          <a:xfrm>
-            <a:off x="731520" y="6510528"/>
-            <a:ext cx="10725912" cy="228600"/>
-          </a:xfrm>
-          <a:prstGeom prst="rect">
-            <a:avLst/>
-          </a:prstGeom>
-        </p:spPr>
-        <p:txBody>
-          <a:bodyPr anchor="t"/>
-          <a:lstStyle/>
-          <a:p>
-            <a:pPr algn="ctr"/>
-            <a:r>
-              <a:rPr i="1" sz="800">
-                <a:solidFill>
-                  <a:srgbClr val="94A3B8"/>
-                </a:solidFill>
-                <a:latin typeface="+mn-lt"/>
-                <a:cs typeface="+mn-lt"/>
-              </a:rPr>
-              <a:t>* Disclaimer: All benchmark metrics, performance figures, and simulated architectures in this deck are synthetic demonstration values generated solely to showcase the authoring, formatting, and rendering capabilities of @hokkyss/pptx.</a:t>
             </a:r>
           </a:p>
         </p:txBody>
@@ -7667,7 +7634,7 @@
                       </a:r>
                     </a:p>
                   </a:txBody>
-                  <a:tcPr>
+                  <a:tcPr anchor="ctr">
                     <a:solidFill>
                       <a:srgbClr val="0F172A"/>
                     </a:solidFill>
@@ -7691,7 +7658,7 @@
                       </a:r>
                     </a:p>
                   </a:txBody>
-                  <a:tcPr>
+                  <a:tcPr anchor="ctr">
                     <a:solidFill>
                       <a:srgbClr val="0F172A"/>
                     </a:solidFill>
@@ -7715,7 +7682,7 @@
                       </a:r>
                     </a:p>
                   </a:txBody>
-                  <a:tcPr>
+                  <a:tcPr anchor="ctr">
                     <a:solidFill>
                       <a:srgbClr val="0F172A"/>
                     </a:solidFill>
@@ -7739,7 +7706,7 @@
                       </a:r>
                     </a:p>
                   </a:txBody>
-                  <a:tcPr>
+                  <a:tcPr anchor="ctr">
                     <a:solidFill>
                       <a:srgbClr val="0F172A"/>
                     </a:solidFill>
@@ -7763,7 +7730,7 @@
                       </a:r>
                     </a:p>
                   </a:txBody>
-                  <a:tcPr>
+                  <a:tcPr anchor="ctr">
                     <a:solidFill>
                       <a:srgbClr val="0F172A"/>
                     </a:solidFill>
@@ -7789,7 +7756,7 @@
                       </a:r>
                     </a:p>
                   </a:txBody>
-                  <a:tcPr>
+                  <a:tcPr anchor="ctr">
                     <a:solidFill>
                       <a:srgbClr val="F8FAFC"/>
                     </a:solidFill>
@@ -7813,7 +7780,7 @@
                       </a:r>
                     </a:p>
                   </a:txBody>
-                  <a:tcPr>
+                  <a:tcPr anchor="ctr">
                     <a:solidFill>
                       <a:srgbClr val="F8FAFC"/>
                     </a:solidFill>
@@ -7837,7 +7804,7 @@
                       </a:r>
                     </a:p>
                   </a:txBody>
-                  <a:tcPr>
+                  <a:tcPr anchor="ctr">
                     <a:solidFill>
                       <a:srgbClr val="F8FAFC"/>
                     </a:solidFill>
@@ -7861,7 +7828,7 @@
                       </a:r>
                     </a:p>
                   </a:txBody>
-                  <a:tcPr>
+                  <a:tcPr anchor="ctr">
                     <a:solidFill>
                       <a:srgbClr val="F8FAFC"/>
                     </a:solidFill>
@@ -7885,7 +7852,7 @@
                       </a:r>
                     </a:p>
                   </a:txBody>
-                  <a:tcPr>
+                  <a:tcPr anchor="ctr">
                     <a:solidFill>
                       <a:srgbClr val="ECFDF5"/>
                     </a:solidFill>
@@ -7911,7 +7878,7 @@
                       </a:r>
                     </a:p>
                   </a:txBody>
-                  <a:tcPr>
+                  <a:tcPr anchor="ctr">
                     <a:solidFill>
                       <a:srgbClr val="FFFFFF"/>
                     </a:solidFill>
@@ -7935,7 +7902,7 @@
                       </a:r>
                     </a:p>
                   </a:txBody>
-                  <a:tcPr>
+                  <a:tcPr anchor="ctr">
                     <a:solidFill>
                       <a:srgbClr val="FFFFFF"/>
                     </a:solidFill>
@@ -7959,7 +7926,7 @@
                       </a:r>
                     </a:p>
                   </a:txBody>
-                  <a:tcPr>
+                  <a:tcPr anchor="ctr">
                     <a:solidFill>
                       <a:srgbClr val="FFFFFF"/>
                     </a:solidFill>
@@ -7983,7 +7950,7 @@
                       </a:r>
                     </a:p>
                   </a:txBody>
-                  <a:tcPr>
+                  <a:tcPr anchor="ctr">
                     <a:solidFill>
                       <a:srgbClr val="FFFFFF"/>
                     </a:solidFill>
@@ -8007,7 +7974,7 @@
                       </a:r>
                     </a:p>
                   </a:txBody>
-                  <a:tcPr>
+                  <a:tcPr anchor="ctr">
                     <a:solidFill>
                       <a:srgbClr val="ECFDF5"/>
                     </a:solidFill>
@@ -8033,7 +8000,7 @@
                       </a:r>
                     </a:p>
                   </a:txBody>
-                  <a:tcPr>
+                  <a:tcPr anchor="ctr">
                     <a:solidFill>
                       <a:srgbClr val="F8FAFC"/>
                     </a:solidFill>
@@ -8057,7 +8024,7 @@
                       </a:r>
                     </a:p>
                   </a:txBody>
-                  <a:tcPr>
+                  <a:tcPr anchor="ctr">
                     <a:solidFill>
                       <a:srgbClr val="F8FAFC"/>
                     </a:solidFill>
@@ -8081,7 +8048,7 @@
                       </a:r>
                     </a:p>
                   </a:txBody>
-                  <a:tcPr>
+                  <a:tcPr anchor="ctr">
                     <a:solidFill>
                       <a:srgbClr val="F8FAFC"/>
                     </a:solidFill>
@@ -8105,7 +8072,7 @@
                       </a:r>
                     </a:p>
                   </a:txBody>
-                  <a:tcPr>
+                  <a:tcPr anchor="ctr">
                     <a:solidFill>
                       <a:srgbClr val="F8FAFC"/>
                     </a:solidFill>
@@ -8129,7 +8096,7 @@
                       </a:r>
                     </a:p>
                   </a:txBody>
-                  <a:tcPr>
+                  <a:tcPr anchor="ctr">
                     <a:solidFill>
                       <a:srgbClr val="ECFDF5"/>
                     </a:solidFill>
@@ -8155,7 +8122,7 @@
                       </a:r>
                     </a:p>
                   </a:txBody>
-                  <a:tcPr>
+                  <a:tcPr anchor="ctr">
                     <a:solidFill>
                       <a:srgbClr val="FFFFFF"/>
                     </a:solidFill>
@@ -8179,7 +8146,7 @@
                       </a:r>
                     </a:p>
                   </a:txBody>
-                  <a:tcPr>
+                  <a:tcPr anchor="ctr">
                     <a:solidFill>
                       <a:srgbClr val="FFFFFF"/>
                     </a:solidFill>
@@ -8203,7 +8170,7 @@
                       </a:r>
                     </a:p>
                   </a:txBody>
-                  <a:tcPr>
+                  <a:tcPr anchor="ctr">
                     <a:solidFill>
                       <a:srgbClr val="FFFFFF"/>
                     </a:solidFill>
@@ -8227,7 +8194,7 @@
                       </a:r>
                     </a:p>
                   </a:txBody>
-                  <a:tcPr>
+                  <a:tcPr anchor="ctr">
                     <a:solidFill>
                       <a:srgbClr val="FFFFFF"/>
                     </a:solidFill>
@@ -8251,7 +8218,7 @@
                       </a:r>
                     </a:p>
                   </a:txBody>
-                  <a:tcPr>
+                  <a:tcPr anchor="ctr">
                     <a:solidFill>
                       <a:srgbClr val="ECFDF5"/>
                     </a:solidFill>
@@ -8277,7 +8244,7 @@
                       </a:r>
                     </a:p>
                   </a:txBody>
-                  <a:tcPr>
+                  <a:tcPr anchor="ctr">
                     <a:solidFill>
                       <a:srgbClr val="F8FAFC"/>
                     </a:solidFill>
@@ -8301,7 +8268,7 @@
                       </a:r>
                     </a:p>
                   </a:txBody>
-                  <a:tcPr>
+                  <a:tcPr anchor="ctr">
                     <a:solidFill>
                       <a:srgbClr val="F8FAFC"/>
                     </a:solidFill>
@@ -8325,7 +8292,7 @@
                       </a:r>
                     </a:p>
                   </a:txBody>
-                  <a:tcPr>
+                  <a:tcPr anchor="ctr">
                     <a:solidFill>
                       <a:srgbClr val="F8FAFC"/>
                     </a:solidFill>
@@ -8349,7 +8316,7 @@
                       </a:r>
                     </a:p>
                   </a:txBody>
-                  <a:tcPr>
+                  <a:tcPr anchor="ctr">
                     <a:solidFill>
                       <a:srgbClr val="F8FAFC"/>
                     </a:solidFill>
@@ -8373,7 +8340,7 @@
                       </a:r>
                     </a:p>
                   </a:txBody>
-                  <a:tcPr>
+                  <a:tcPr anchor="ctr">
                     <a:solidFill>
                       <a:srgbClr val="FEF2F2"/>
                     </a:solidFill>
@@ -8384,6 +8351,39 @@
           </a:graphicData>
         </a:graphic>
       </p:graphicFrame>
+      <p:sp>
+        <p:nvSpPr>
+          <p:cNvPr id="5" name="Text Box 4"/>
+          <p:cNvSpPr/>
+          <p:nvPr/>
+        </p:nvSpPr>
+        <p:spPr>
+          <a:xfrm>
+            <a:off x="731520" y="6510528"/>
+            <a:ext cx="10725912" cy="228600"/>
+          </a:xfrm>
+          <a:prstGeom prst="rect">
+            <a:avLst/>
+          </a:prstGeom>
+        </p:spPr>
+        <p:txBody>
+          <a:bodyPr anchor="t"/>
+          <a:lstStyle/>
+          <a:p>
+            <a:pPr algn="ctr"/>
+            <a:r>
+              <a:rPr i="1" sz="800">
+                <a:solidFill>
+                  <a:srgbClr val="94A3B8"/>
+                </a:solidFill>
+                <a:latin typeface="+mn-lt"/>
+                <a:cs typeface="+mn-lt"/>
+              </a:rPr>
+              <a:t>* Disclaimer: All benchmark metrics, performance figures, and simulated architectures in this deck are synthetic demonstration values generated solely to showcase the authoring, formatting, and rendering capabilities of @hokkyss/pptx.</a:t>
+            </a:r>
+          </a:p>
+        </p:txBody>
+      </p:sp>
     </p:spTree>
   </p:cSld>
   <p:clrMapOvr>
@@ -8396,7 +8396,7 @@
 </file>
 
 <file path=ppt/slides/slide4.xml><?xml version="1.0" encoding="utf-8"?>
-<p:sld xmlns:a="http://schemas.openxmlformats.org/drawingml/2006/main" xmlns:r="http://schemas.openxmlformats.org/officeDocument/2006/relationships" xmlns:p="http://schemas.openxmlformats.org/presentationml/2006/main">
+<p:sld xmlns:a="http://schemas.openxmlformats.org/drawingml/2006/main" xmlns:p="http://schemas.openxmlformats.org/presentationml/2006/main" xmlns:r="http://schemas.openxmlformats.org/officeDocument/2006/relationships">
   <p:cSld>
     <p:bg>
       <p:bgPr>
@@ -8802,7 +8802,7 @@
 </file>
 
 <file path=ppt/slides/slide5.xml><?xml version="1.0" encoding="utf-8"?>
-<p:sld xmlns:a="http://schemas.openxmlformats.org/drawingml/2006/main" xmlns:r="http://schemas.openxmlformats.org/officeDocument/2006/relationships" xmlns:p="http://schemas.openxmlformats.org/presentationml/2006/main">
+<p:sld xmlns:a="http://schemas.openxmlformats.org/drawingml/2006/main" xmlns:p="http://schemas.openxmlformats.org/presentationml/2006/main" xmlns:r="http://schemas.openxmlformats.org/officeDocument/2006/relationships">
   <p:cSld>
     <p:bg>
       <p:bgPr>
@@ -9450,7 +9450,7 @@
 </file>
 
 <file path=ppt/slides/slide6.xml><?xml version="1.0" encoding="utf-8"?>
-<p:sld xmlns:a="http://schemas.openxmlformats.org/drawingml/2006/main" xmlns:r="http://schemas.openxmlformats.org/officeDocument/2006/relationships" xmlns:p="http://schemas.openxmlformats.org/presentationml/2006/main">
+<p:sld xmlns:a="http://schemas.openxmlformats.org/drawingml/2006/main" xmlns:p="http://schemas.openxmlformats.org/presentationml/2006/main" xmlns:r="http://schemas.openxmlformats.org/officeDocument/2006/relationships">
   <p:cSld>
     <p:bg>
       <p:bgPr>
@@ -9578,6 +9578,30 @@
           </a:p>
         </p:txBody>
       </p:sp>
+      <p:pic>
+        <p:nvPicPr>
+          <p:cNvPr id="5" name="Picture 4"/>
+          <p:cNvPicPr>
+            <a:picLocks noChangeAspect="1"/>
+          </p:cNvPicPr>
+          <p:nvPr/>
+        </p:nvPicPr>
+        <p:blipFill>
+          <a:blip r:embed="rId2"/>
+          <a:stretch>
+            <a:fillRect/>
+          </a:stretch>
+        </p:blipFill>
+        <p:spPr>
+          <a:xfrm>
+            <a:off x="1188720" y="2103120"/>
+            <a:ext cx="4389120" cy="2468880"/>
+          </a:xfrm>
+          <a:prstGeom prst="rect">
+            <a:avLst/>
+          </a:prstGeom>
+        </p:spPr>
+      </p:pic>
       <p:sp>
         <p:nvSpPr>
           <p:cNvPr id="6" name="Text Box 5"/>
@@ -9708,176 +9732,6 @@
           </a:p>
         </p:txBody>
       </p:sp>
-      <p:sp>
-        <p:nvSpPr>
-          <p:cNvPr id="11" name="Text Box 10"/>
-          <p:cNvSpPr/>
-          <p:nvPr/>
-        </p:nvSpPr>
-        <p:spPr>
-          <a:xfrm>
-            <a:off x="6611112" y="3383280"/>
-            <a:ext cx="4389120" cy="365760"/>
-          </a:xfrm>
-          <a:prstGeom prst="rect">
-            <a:avLst/>
-          </a:prstGeom>
-        </p:spPr>
-        <p:txBody>
-          <a:bodyPr anchor="t"/>
-          <a:lstStyle/>
-          <a:p>
-            <a:pPr algn="l"/>
-            <a:r>
-              <a:rPr b="1" sz="1500">
-                <a:solidFill>
-                  <a:srgbClr val="0F172A"/>
-                </a:solidFill>
-                <a:latin typeface="+mn-lt"/>
-                <a:cs typeface="+mn-lt"/>
-              </a:rPr>
-              <a:t>Supported Image Codecs &amp; Features</a:t>
-            </a:r>
-          </a:p>
-        </p:txBody>
-      </p:sp>
-      <p:sp>
-        <p:nvSpPr>
-          <p:cNvPr id="12" name="Text Box 11"/>
-          <p:cNvSpPr/>
-          <p:nvPr/>
-        </p:nvSpPr>
-        <p:spPr>
-          <a:xfrm>
-            <a:off x="6611112" y="3840480"/>
-            <a:ext cx="4389120" cy="2011680"/>
-          </a:xfrm>
-          <a:prstGeom prst="rect">
-            <a:avLst/>
-          </a:prstGeom>
-        </p:spPr>
-        <p:txBody>
-          <a:bodyPr anchor="t"/>
-          <a:lstStyle/>
-          <a:p>
-            <a:pPr algn="l" lvl="0" marL="152400" indent="-152400">
-              <a:buChar char="•"/>
-            </a:pPr>
-            <a:r>
-              <a:rPr sz="1100">
-                <a:solidFill>
-                  <a:srgbClr val="475569"/>
-                </a:solidFill>
-                <a:latin typeface="+mn-lt"/>
-                <a:cs typeface="+mn-lt"/>
-              </a:rPr>
-              <a:t>PNG with 32-bit RGBA alpha transparency</a:t>
-            </a:r>
-          </a:p>
-          <a:p>
-            <a:pPr algn="l" lvl="0" marL="152400" indent="-152400">
-              <a:buChar char="•"/>
-            </a:pPr>
-            <a:r>
-              <a:rPr sz="1100">
-                <a:solidFill>
-                  <a:srgbClr val="475569"/>
-                </a:solidFill>
-                <a:latin typeface="+mn-lt"/>
-                <a:cs typeface="+mn-lt"/>
-              </a:rPr>
-              <a:t>JPEG / JPG progressive and baseline encoding</a:t>
-            </a:r>
-          </a:p>
-          <a:p>
-            <a:pPr algn="l" lvl="0" marL="152400" indent="-152400">
-              <a:buChar char="•"/>
-            </a:pPr>
-            <a:r>
-              <a:rPr sz="1100">
-                <a:solidFill>
-                  <a:srgbClr val="475569"/>
-                </a:solidFill>
-                <a:latin typeface="+mn-lt"/>
-                <a:cs typeface="+mn-lt"/>
-              </a:rPr>
-              <a:t>Zero-copy ArrayBuffer &amp; Uint8Array input</a:t>
-            </a:r>
-          </a:p>
-          <a:p>
-            <a:pPr algn="l" lvl="0" marL="152400" indent="-152400">
-              <a:buChar char="•"/>
-            </a:pPr>
-            <a:r>
-              <a:rPr sz="1100">
-                <a:solidFill>
-                  <a:srgbClr val="475569"/>
-                </a:solidFill>
-                <a:latin typeface="+mn-lt"/>
-                <a:cs typeface="+mn-lt"/>
-              </a:rPr>
-              <a:t>Placeholder resolution into slide layout picture frames</a:t>
-            </a:r>
-          </a:p>
-        </p:txBody>
-      </p:sp>
-      <p:sp>
-        <p:nvSpPr>
-          <p:cNvPr id="13" name="Text Box 12"/>
-          <p:cNvSpPr/>
-          <p:nvPr/>
-        </p:nvSpPr>
-        <p:spPr>
-          <a:xfrm>
-            <a:off x="731520" y="6510528"/>
-            <a:ext cx="10725912" cy="228600"/>
-          </a:xfrm>
-          <a:prstGeom prst="rect">
-            <a:avLst/>
-          </a:prstGeom>
-        </p:spPr>
-        <p:txBody>
-          <a:bodyPr anchor="t"/>
-          <a:lstStyle/>
-          <a:p>
-            <a:pPr algn="ctr"/>
-            <a:r>
-              <a:rPr i="1" sz="800">
-                <a:solidFill>
-                  <a:srgbClr val="94A3B8"/>
-                </a:solidFill>
-                <a:latin typeface="+mn-lt"/>
-                <a:cs typeface="+mn-lt"/>
-              </a:rPr>
-              <a:t>* Disclaimer: All benchmark metrics, performance figures, and simulated architectures in this deck are synthetic demonstration values generated solely to showcase the authoring, formatting, and rendering capabilities of @hokkyss/pptx.</a:t>
-            </a:r>
-          </a:p>
-        </p:txBody>
-      </p:sp>
-      <p:pic>
-        <p:nvPicPr>
-          <p:cNvPr id="5" name="Picture 4"/>
-          <p:cNvPicPr>
-            <a:picLocks noChangeAspect="1"/>
-          </p:cNvPicPr>
-          <p:nvPr/>
-        </p:nvPicPr>
-        <p:blipFill>
-          <a:blip r:embed="rId2"/>
-          <a:stretch>
-            <a:fillRect/>
-          </a:stretch>
-        </p:blipFill>
-        <p:spPr>
-          <a:xfrm>
-            <a:off x="1188720" y="2103120"/>
-            <a:ext cx="4389120" cy="2468880"/>
-          </a:xfrm>
-          <a:prstGeom prst="rect">
-            <a:avLst/>
-          </a:prstGeom>
-        </p:spPr>
-      </p:pic>
       <p:pic>
         <p:nvPicPr>
           <p:cNvPr id="10" name="Picture 9"/>
@@ -9902,6 +9756,152 @@
           </a:prstGeom>
         </p:spPr>
       </p:pic>
+      <p:sp>
+        <p:nvSpPr>
+          <p:cNvPr id="11" name="Text Box 10"/>
+          <p:cNvSpPr/>
+          <p:nvPr/>
+        </p:nvSpPr>
+        <p:spPr>
+          <a:xfrm>
+            <a:off x="6611112" y="3383280"/>
+            <a:ext cx="4389120" cy="365760"/>
+          </a:xfrm>
+          <a:prstGeom prst="rect">
+            <a:avLst/>
+          </a:prstGeom>
+        </p:spPr>
+        <p:txBody>
+          <a:bodyPr anchor="t"/>
+          <a:lstStyle/>
+          <a:p>
+            <a:pPr algn="l"/>
+            <a:r>
+              <a:rPr b="1" sz="1500">
+                <a:solidFill>
+                  <a:srgbClr val="0F172A"/>
+                </a:solidFill>
+                <a:latin typeface="+mn-lt"/>
+                <a:cs typeface="+mn-lt"/>
+              </a:rPr>
+              <a:t>Supported Image Codecs &amp; Features</a:t>
+            </a:r>
+          </a:p>
+        </p:txBody>
+      </p:sp>
+      <p:sp>
+        <p:nvSpPr>
+          <p:cNvPr id="12" name="Text Box 11"/>
+          <p:cNvSpPr/>
+          <p:nvPr/>
+        </p:nvSpPr>
+        <p:spPr>
+          <a:xfrm>
+            <a:off x="6611112" y="3840480"/>
+            <a:ext cx="4389120" cy="2011680"/>
+          </a:xfrm>
+          <a:prstGeom prst="rect">
+            <a:avLst/>
+          </a:prstGeom>
+        </p:spPr>
+        <p:txBody>
+          <a:bodyPr anchor="t"/>
+          <a:lstStyle/>
+          <a:p>
+            <a:pPr algn="l" lvl="0" marL="152400" indent="-152400">
+              <a:buChar char="•"/>
+            </a:pPr>
+            <a:r>
+              <a:rPr sz="1100">
+                <a:solidFill>
+                  <a:srgbClr val="475569"/>
+                </a:solidFill>
+                <a:latin typeface="+mn-lt"/>
+                <a:cs typeface="+mn-lt"/>
+              </a:rPr>
+              <a:t>PNG with 32-bit RGBA alpha transparency</a:t>
+            </a:r>
+          </a:p>
+          <a:p>
+            <a:pPr algn="l" lvl="0" marL="152400" indent="-152400">
+              <a:buChar char="•"/>
+            </a:pPr>
+            <a:r>
+              <a:rPr sz="1100">
+                <a:solidFill>
+                  <a:srgbClr val="475569"/>
+                </a:solidFill>
+                <a:latin typeface="+mn-lt"/>
+                <a:cs typeface="+mn-lt"/>
+              </a:rPr>
+              <a:t>JPEG / JPG progressive and baseline encoding</a:t>
+            </a:r>
+          </a:p>
+          <a:p>
+            <a:pPr algn="l" lvl="0" marL="152400" indent="-152400">
+              <a:buChar char="•"/>
+            </a:pPr>
+            <a:r>
+              <a:rPr sz="1100">
+                <a:solidFill>
+                  <a:srgbClr val="475569"/>
+                </a:solidFill>
+                <a:latin typeface="+mn-lt"/>
+                <a:cs typeface="+mn-lt"/>
+              </a:rPr>
+              <a:t>Zero-copy ArrayBuffer &amp; Uint8Array input</a:t>
+            </a:r>
+          </a:p>
+          <a:p>
+            <a:pPr algn="l" lvl="0" marL="152400" indent="-152400">
+              <a:buChar char="•"/>
+            </a:pPr>
+            <a:r>
+              <a:rPr sz="1100">
+                <a:solidFill>
+                  <a:srgbClr val="475569"/>
+                </a:solidFill>
+                <a:latin typeface="+mn-lt"/>
+                <a:cs typeface="+mn-lt"/>
+              </a:rPr>
+              <a:t>Placeholder resolution into slide layout picture frames</a:t>
+            </a:r>
+          </a:p>
+        </p:txBody>
+      </p:sp>
+      <p:sp>
+        <p:nvSpPr>
+          <p:cNvPr id="13" name="Text Box 12"/>
+          <p:cNvSpPr/>
+          <p:nvPr/>
+        </p:nvSpPr>
+        <p:spPr>
+          <a:xfrm>
+            <a:off x="731520" y="6510528"/>
+            <a:ext cx="10725912" cy="228600"/>
+          </a:xfrm>
+          <a:prstGeom prst="rect">
+            <a:avLst/>
+          </a:prstGeom>
+        </p:spPr>
+        <p:txBody>
+          <a:bodyPr anchor="t"/>
+          <a:lstStyle/>
+          <a:p>
+            <a:pPr algn="ctr"/>
+            <a:r>
+              <a:rPr i="1" sz="800">
+                <a:solidFill>
+                  <a:srgbClr val="94A3B8"/>
+                </a:solidFill>
+                <a:latin typeface="+mn-lt"/>
+                <a:cs typeface="+mn-lt"/>
+              </a:rPr>
+              <a:t>* Disclaimer: All benchmark metrics, performance figures, and simulated architectures in this deck are synthetic demonstration values generated solely to showcase the authoring, formatting, and rendering capabilities of @hokkyss/pptx.</a:t>
+            </a:r>
+          </a:p>
+        </p:txBody>
+      </p:sp>
     </p:spTree>
   </p:cSld>
   <p:clrMapOvr>
@@ -9914,7 +9914,7 @@
 </file>
 
 <file path=ppt/slides/slide7.xml><?xml version="1.0" encoding="utf-8"?>
-<p:sld xmlns:a="http://schemas.openxmlformats.org/drawingml/2006/main" xmlns:r="http://schemas.openxmlformats.org/officeDocument/2006/relationships" xmlns:p="http://schemas.openxmlformats.org/presentationml/2006/main">
+<p:sld xmlns:a="http://schemas.openxmlformats.org/drawingml/2006/main" xmlns:p="http://schemas.openxmlformats.org/presentationml/2006/main" xmlns:r="http://schemas.openxmlformats.org/officeDocument/2006/relationships">
   <p:cSld>
     <p:bg>
       <p:bgPr>
@@ -10531,7 +10531,7 @@
 </file>
 
 <file path=ppt/slides/slide8.xml><?xml version="1.0" encoding="utf-8"?>
-<p:sld xmlns:a="http://schemas.openxmlformats.org/drawingml/2006/main" xmlns:r="http://schemas.openxmlformats.org/officeDocument/2006/relationships" xmlns:p="http://schemas.openxmlformats.org/presentationml/2006/main">
+<p:sld xmlns:a="http://schemas.openxmlformats.org/drawingml/2006/main" xmlns:p="http://schemas.openxmlformats.org/presentationml/2006/main" xmlns:r="http://schemas.openxmlformats.org/officeDocument/2006/relationships">
   <p:cSld>
     <p:bg>
       <p:bgPr>
@@ -10617,72 +10617,6 @@
                 <a:cs typeface="+mn-lt"/>
               </a:rPr>
               <a:t>Demonstrating vector connectors (solid, dashed), coordinates, and composite group containers (addGroup)</a:t>
-            </a:r>
-          </a:p>
-        </p:txBody>
-      </p:sp>
-      <p:sp>
-        <p:nvSpPr>
-          <p:cNvPr id="19" name="Text Box 18"/>
-          <p:cNvSpPr/>
-          <p:nvPr/>
-        </p:nvSpPr>
-        <p:spPr>
-          <a:xfrm>
-            <a:off x="914400" y="5806440"/>
-            <a:ext cx="10241280" cy="365760"/>
-          </a:xfrm>
-          <a:prstGeom prst="rect">
-            <a:avLst/>
-          </a:prstGeom>
-        </p:spPr>
-        <p:txBody>
-          <a:bodyPr anchor="t"/>
-          <a:lstStyle/>
-          <a:p>
-            <a:pPr algn="ctr"/>
-            <a:r>
-              <a:rPr sz="1100">
-                <a:solidFill>
-                  <a:srgbClr val="64748B"/>
-                </a:solidFill>
-                <a:latin typeface="+mn-lt"/>
-                <a:cs typeface="+mn-lt"/>
-              </a:rPr>
-              <a:t>Isomorphic Pipeline Feedback Loop: 100% Roundtrip Bit-Exact Precision</a:t>
-            </a:r>
-          </a:p>
-        </p:txBody>
-      </p:sp>
-      <p:sp>
-        <p:nvSpPr>
-          <p:cNvPr id="20" name="Text Box 19"/>
-          <p:cNvSpPr/>
-          <p:nvPr/>
-        </p:nvSpPr>
-        <p:spPr>
-          <a:xfrm>
-            <a:off x="731520" y="6510528"/>
-            <a:ext cx="10725912" cy="228600"/>
-          </a:xfrm>
-          <a:prstGeom prst="rect">
-            <a:avLst/>
-          </a:prstGeom>
-        </p:spPr>
-        <p:txBody>
-          <a:bodyPr anchor="t"/>
-          <a:lstStyle/>
-          <a:p>
-            <a:pPr algn="ctr"/>
-            <a:r>
-              <a:rPr i="1" sz="800">
-                <a:solidFill>
-                  <a:srgbClr val="94A3B8"/>
-                </a:solidFill>
-                <a:latin typeface="+mn-lt"/>
-                <a:cs typeface="+mn-lt"/>
-              </a:rPr>
-              <a:t>* Disclaimer: All benchmark metrics, performance figures, and simulated architectures in this deck are synthetic demonstration values generated solely to showcase the authoring, formatting, and rendering capabilities of @hokkyss/pptx.</a:t>
             </a:r>
           </a:p>
         </p:txBody>
@@ -11229,6 +11163,72 @@
           </a:ln>
         </p:spPr>
       </p:cxnSp>
+      <p:sp>
+        <p:nvSpPr>
+          <p:cNvPr id="19" name="Text Box 18"/>
+          <p:cNvSpPr/>
+          <p:nvPr/>
+        </p:nvSpPr>
+        <p:spPr>
+          <a:xfrm>
+            <a:off x="914400" y="5806440"/>
+            <a:ext cx="10241280" cy="365760"/>
+          </a:xfrm>
+          <a:prstGeom prst="rect">
+            <a:avLst/>
+          </a:prstGeom>
+        </p:spPr>
+        <p:txBody>
+          <a:bodyPr anchor="t"/>
+          <a:lstStyle/>
+          <a:p>
+            <a:pPr algn="ctr"/>
+            <a:r>
+              <a:rPr sz="1100">
+                <a:solidFill>
+                  <a:srgbClr val="64748B"/>
+                </a:solidFill>
+                <a:latin typeface="+mn-lt"/>
+                <a:cs typeface="+mn-lt"/>
+              </a:rPr>
+              <a:t>Isomorphic Pipeline Feedback Loop: 100% Roundtrip Bit-Exact Precision</a:t>
+            </a:r>
+          </a:p>
+        </p:txBody>
+      </p:sp>
+      <p:sp>
+        <p:nvSpPr>
+          <p:cNvPr id="20" name="Text Box 19"/>
+          <p:cNvSpPr/>
+          <p:nvPr/>
+        </p:nvSpPr>
+        <p:spPr>
+          <a:xfrm>
+            <a:off x="731520" y="6510528"/>
+            <a:ext cx="10725912" cy="228600"/>
+          </a:xfrm>
+          <a:prstGeom prst="rect">
+            <a:avLst/>
+          </a:prstGeom>
+        </p:spPr>
+        <p:txBody>
+          <a:bodyPr anchor="t"/>
+          <a:lstStyle/>
+          <a:p>
+            <a:pPr algn="ctr"/>
+            <a:r>
+              <a:rPr i="1" sz="800">
+                <a:solidFill>
+                  <a:srgbClr val="94A3B8"/>
+                </a:solidFill>
+                <a:latin typeface="+mn-lt"/>
+                <a:cs typeface="+mn-lt"/>
+              </a:rPr>
+              <a:t>* Disclaimer: All benchmark metrics, performance figures, and simulated architectures in this deck are synthetic demonstration values generated solely to showcase the authoring, formatting, and rendering capabilities of @hokkyss/pptx.</a:t>
+            </a:r>
+          </a:p>
+        </p:txBody>
+      </p:sp>
     </p:spTree>
   </p:cSld>
   <p:clrMapOvr>
@@ -11241,7 +11241,7 @@
 </file>
 
 <file path=ppt/slides/slide9.xml><?xml version="1.0" encoding="utf-8"?>
-<p:sld xmlns:a="http://schemas.openxmlformats.org/drawingml/2006/main" xmlns:r="http://schemas.openxmlformats.org/officeDocument/2006/relationships" xmlns:p="http://schemas.openxmlformats.org/presentationml/2006/main">
+<p:sld xmlns:a="http://schemas.openxmlformats.org/drawingml/2006/main" xmlns:p="http://schemas.openxmlformats.org/presentationml/2006/main" xmlns:r="http://schemas.openxmlformats.org/officeDocument/2006/relationships">
   <p:cSld>
     <p:bg>
       <p:bgPr>
@@ -11369,261 +11369,6 @@
           </a:p>
         </p:txBody>
       </p:sp>
-      <p:sp>
-        <p:nvSpPr>
-          <p:cNvPr id="6" name="roundRect 5"/>
-          <p:cNvSpPr/>
-          <p:nvPr/>
-        </p:nvSpPr>
-        <p:spPr>
-          <a:xfrm>
-            <a:off x="7589520" y="1828800"/>
-            <a:ext cx="3657600" cy="1234440"/>
-          </a:xfrm>
-          <a:prstGeom prst="roundRect">
-            <a:avLst/>
-          </a:prstGeom>
-          <a:solidFill>
-            <a:srgbClr val="1E293B"/>
-          </a:solidFill>
-          <a:ln w="13716">
-            <a:solidFill>
-              <a:srgbClr val="0284C7"/>
-            </a:solidFill>
-          </a:ln>
-        </p:spPr>
-        <p:txBody>
-          <a:bodyPr anchor="t"/>
-          <a:lstStyle/>
-          <a:p>
-            <a:pPr algn="l"/>
-            <a:r>
-              <a:rPr b="1" sz="1300">
-                <a:solidFill>
-                  <a:srgbClr val="38BDF8"/>
-                </a:solidFill>
-                <a:latin typeface="+mn-lt"/>
-                <a:cs typeface="+mn-lt"/>
-              </a:rPr>
-              <a:t>⚡ Zero Native Bindings</a:t>
-            </a:r>
-          </a:p>
-        </p:txBody>
-      </p:sp>
-      <p:sp>
-        <p:nvSpPr>
-          <p:cNvPr id="7" name="Text Box 6"/>
-          <p:cNvSpPr/>
-          <p:nvPr/>
-        </p:nvSpPr>
-        <p:spPr>
-          <a:xfrm>
-            <a:off x="7772400" y="2240280"/>
-            <a:ext cx="3291840" cy="731520"/>
-          </a:xfrm>
-          <a:prstGeom prst="rect">
-            <a:avLst/>
-          </a:prstGeom>
-        </p:spPr>
-        <p:txBody>
-          <a:bodyPr anchor="t"/>
-          <a:lstStyle/>
-          <a:p>
-            <a:pPr algn="l"/>
-            <a:r>
-              <a:rPr sz="1000">
-                <a:solidFill>
-                  <a:srgbClr val="94A3B8"/>
-                </a:solidFill>
-                <a:latin typeface="+mn-lt"/>
-                <a:cs typeface="+mn-lt"/>
-              </a:rPr>
-              <a:t>Generates ECMA-376 compliant DrawingML charts directly from pure TypeScript arrays without spawning Python, Java, or Excel subprocesses.</a:t>
-            </a:r>
-          </a:p>
-        </p:txBody>
-      </p:sp>
-      <p:sp>
-        <p:nvSpPr>
-          <p:cNvPr id="8" name="roundRect 7"/>
-          <p:cNvSpPr/>
-          <p:nvPr/>
-        </p:nvSpPr>
-        <p:spPr>
-          <a:xfrm>
-            <a:off x="7589520" y="3246120"/>
-            <a:ext cx="3657600" cy="1234440"/>
-          </a:xfrm>
-          <a:prstGeom prst="roundRect">
-            <a:avLst/>
-          </a:prstGeom>
-          <a:solidFill>
-            <a:srgbClr val="1E293B"/>
-          </a:solidFill>
-          <a:ln w="13716">
-            <a:solidFill>
-              <a:srgbClr val="10B981"/>
-            </a:solidFill>
-          </a:ln>
-        </p:spPr>
-        <p:txBody>
-          <a:bodyPr anchor="t"/>
-          <a:lstStyle/>
-          <a:p>
-            <a:pPr algn="l"/>
-            <a:r>
-              <a:rPr b="1" sz="1300">
-                <a:solidFill>
-                  <a:srgbClr val="34D399"/>
-                </a:solidFill>
-                <a:latin typeface="+mn-lt"/>
-                <a:cs typeface="+mn-lt"/>
-              </a:rPr>
-              <a:t>📈 Fully Editable &amp; Scalable</a:t>
-            </a:r>
-          </a:p>
-        </p:txBody>
-      </p:sp>
-      <p:sp>
-        <p:nvSpPr>
-          <p:cNvPr id="9" name="Text Box 8"/>
-          <p:cNvSpPr/>
-          <p:nvPr/>
-        </p:nvSpPr>
-        <p:spPr>
-          <a:xfrm>
-            <a:off x="7772400" y="3657600"/>
-            <a:ext cx="3291840" cy="731520"/>
-          </a:xfrm>
-          <a:prstGeom prst="rect">
-            <a:avLst/>
-          </a:prstGeom>
-        </p:spPr>
-        <p:txBody>
-          <a:bodyPr anchor="t"/>
-          <a:lstStyle/>
-          <a:p>
-            <a:pPr algn="l"/>
-            <a:r>
-              <a:rPr sz="1000">
-                <a:solidFill>
-                  <a:srgbClr val="94A3B8"/>
-                </a:solidFill>
-                <a:latin typeface="+mn-lt"/>
-                <a:cs typeface="+mn-lt"/>
-              </a:rPr>
-              <a:t>Embedded as vector OpenXML chart spaces. Users can edit values, change themes, or modify series formatting natively inside Microsoft PowerPoint.</a:t>
-            </a:r>
-          </a:p>
-        </p:txBody>
-      </p:sp>
-      <p:sp>
-        <p:nvSpPr>
-          <p:cNvPr id="10" name="roundRect 9"/>
-          <p:cNvSpPr/>
-          <p:nvPr/>
-        </p:nvSpPr>
-        <p:spPr>
-          <a:xfrm>
-            <a:off x="7589520" y="4663440"/>
-            <a:ext cx="3657600" cy="1234440"/>
-          </a:xfrm>
-          <a:prstGeom prst="roundRect">
-            <a:avLst/>
-          </a:prstGeom>
-          <a:solidFill>
-            <a:srgbClr val="1E293B"/>
-          </a:solidFill>
-          <a:ln w="13716">
-            <a:solidFill>
-              <a:srgbClr val="6366F1"/>
-            </a:solidFill>
-          </a:ln>
-        </p:spPr>
-        <p:txBody>
-          <a:bodyPr anchor="t"/>
-          <a:lstStyle/>
-          <a:p>
-            <a:pPr algn="l"/>
-            <a:r>
-              <a:rPr b="1" sz="1300">
-                <a:solidFill>
-                  <a:srgbClr val="818CF8"/>
-                </a:solidFill>
-                <a:latin typeface="+mn-lt"/>
-                <a:cs typeface="+mn-lt"/>
-              </a:rPr>
-              <a:t>🎨 Multi-Type Chart Engine</a:t>
-            </a:r>
-          </a:p>
-        </p:txBody>
-      </p:sp>
-      <p:sp>
-        <p:nvSpPr>
-          <p:cNvPr id="11" name="Text Box 10"/>
-          <p:cNvSpPr/>
-          <p:nvPr/>
-        </p:nvSpPr>
-        <p:spPr>
-          <a:xfrm>
-            <a:off x="7772400" y="5074920"/>
-            <a:ext cx="3291840" cy="731520"/>
-          </a:xfrm>
-          <a:prstGeom prst="rect">
-            <a:avLst/>
-          </a:prstGeom>
-        </p:spPr>
-        <p:txBody>
-          <a:bodyPr anchor="t"/>
-          <a:lstStyle/>
-          <a:p>
-            <a:pPr algn="l"/>
-            <a:r>
-              <a:rPr sz="1000">
-                <a:solidFill>
-                  <a:srgbClr val="94A3B8"/>
-                </a:solidFill>
-                <a:latin typeface="+mn-lt"/>
-                <a:cs typeface="+mn-lt"/>
-              </a:rPr>
-              <a:t>Supports column, bar, line, area, and pie chart topologies with custom series coloring, categorical axes, and configurable legend alignments.</a:t>
-            </a:r>
-          </a:p>
-        </p:txBody>
-      </p:sp>
-      <p:sp>
-        <p:nvSpPr>
-          <p:cNvPr id="12" name="Text Box 11"/>
-          <p:cNvSpPr/>
-          <p:nvPr/>
-        </p:nvSpPr>
-        <p:spPr>
-          <a:xfrm>
-            <a:off x="731520" y="6510528"/>
-            <a:ext cx="10725912" cy="228600"/>
-          </a:xfrm>
-          <a:prstGeom prst="rect">
-            <a:avLst/>
-          </a:prstGeom>
-        </p:spPr>
-        <p:txBody>
-          <a:bodyPr anchor="t"/>
-          <a:lstStyle/>
-          <a:p>
-            <a:pPr algn="ctr"/>
-            <a:r>
-              <a:rPr i="1" sz="800">
-                <a:solidFill>
-                  <a:srgbClr val="64748B"/>
-                </a:solidFill>
-                <a:latin typeface="+mn-lt"/>
-                <a:cs typeface="+mn-lt"/>
-              </a:rPr>
-              <a:t>* Disclaimer: All benchmark metrics, performance figures, and simulated architectures in this deck are synthetic demonstration values generated solely to showcase the authoring, formatting, and rendering capabilities of @hokkyss/pptx.</a:t>
-            </a:r>
-          </a:p>
-        </p:txBody>
-      </p:sp>
       <p:graphicFrame>
         <p:nvGraphicFramePr>
           <p:cNvPr id="5" name="Chart 4"/>
@@ -11640,6 +11385,261 @@
           </a:graphicData>
         </a:graphic>
       </p:graphicFrame>
+      <p:sp>
+        <p:nvSpPr>
+          <p:cNvPr id="6" name="roundRect 5"/>
+          <p:cNvSpPr/>
+          <p:nvPr/>
+        </p:nvSpPr>
+        <p:spPr>
+          <a:xfrm>
+            <a:off x="7589520" y="1828800"/>
+            <a:ext cx="3657600" cy="1234440"/>
+          </a:xfrm>
+          <a:prstGeom prst="roundRect">
+            <a:avLst/>
+          </a:prstGeom>
+          <a:solidFill>
+            <a:srgbClr val="1E293B"/>
+          </a:solidFill>
+          <a:ln w="13716">
+            <a:solidFill>
+              <a:srgbClr val="0284C7"/>
+            </a:solidFill>
+          </a:ln>
+        </p:spPr>
+        <p:txBody>
+          <a:bodyPr anchor="t"/>
+          <a:lstStyle/>
+          <a:p>
+            <a:pPr algn="l"/>
+            <a:r>
+              <a:rPr b="1" sz="1300">
+                <a:solidFill>
+                  <a:srgbClr val="38BDF8"/>
+                </a:solidFill>
+                <a:latin typeface="+mn-lt"/>
+                <a:cs typeface="+mn-lt"/>
+              </a:rPr>
+              <a:t>⚡ Zero Native Bindings</a:t>
+            </a:r>
+          </a:p>
+        </p:txBody>
+      </p:sp>
+      <p:sp>
+        <p:nvSpPr>
+          <p:cNvPr id="7" name="Text Box 6"/>
+          <p:cNvSpPr/>
+          <p:nvPr/>
+        </p:nvSpPr>
+        <p:spPr>
+          <a:xfrm>
+            <a:off x="7772400" y="2240280"/>
+            <a:ext cx="3291840" cy="731520"/>
+          </a:xfrm>
+          <a:prstGeom prst="rect">
+            <a:avLst/>
+          </a:prstGeom>
+        </p:spPr>
+        <p:txBody>
+          <a:bodyPr anchor="t"/>
+          <a:lstStyle/>
+          <a:p>
+            <a:pPr algn="l"/>
+            <a:r>
+              <a:rPr sz="1000">
+                <a:solidFill>
+                  <a:srgbClr val="94A3B8"/>
+                </a:solidFill>
+                <a:latin typeface="+mn-lt"/>
+                <a:cs typeface="+mn-lt"/>
+              </a:rPr>
+              <a:t>Generates ECMA-376 compliant DrawingML charts directly from pure TypeScript arrays without spawning Python, Java, or Excel subprocesses.</a:t>
+            </a:r>
+          </a:p>
+        </p:txBody>
+      </p:sp>
+      <p:sp>
+        <p:nvSpPr>
+          <p:cNvPr id="8" name="roundRect 7"/>
+          <p:cNvSpPr/>
+          <p:nvPr/>
+        </p:nvSpPr>
+        <p:spPr>
+          <a:xfrm>
+            <a:off x="7589520" y="3246120"/>
+            <a:ext cx="3657600" cy="1234440"/>
+          </a:xfrm>
+          <a:prstGeom prst="roundRect">
+            <a:avLst/>
+          </a:prstGeom>
+          <a:solidFill>
+            <a:srgbClr val="1E293B"/>
+          </a:solidFill>
+          <a:ln w="13716">
+            <a:solidFill>
+              <a:srgbClr val="10B981"/>
+            </a:solidFill>
+          </a:ln>
+        </p:spPr>
+        <p:txBody>
+          <a:bodyPr anchor="t"/>
+          <a:lstStyle/>
+          <a:p>
+            <a:pPr algn="l"/>
+            <a:r>
+              <a:rPr b="1" sz="1300">
+                <a:solidFill>
+                  <a:srgbClr val="34D399"/>
+                </a:solidFill>
+                <a:latin typeface="+mn-lt"/>
+                <a:cs typeface="+mn-lt"/>
+              </a:rPr>
+              <a:t>📈 Fully Editable &amp; Scalable</a:t>
+            </a:r>
+          </a:p>
+        </p:txBody>
+      </p:sp>
+      <p:sp>
+        <p:nvSpPr>
+          <p:cNvPr id="9" name="Text Box 8"/>
+          <p:cNvSpPr/>
+          <p:nvPr/>
+        </p:nvSpPr>
+        <p:spPr>
+          <a:xfrm>
+            <a:off x="7772400" y="3657600"/>
+            <a:ext cx="3291840" cy="731520"/>
+          </a:xfrm>
+          <a:prstGeom prst="rect">
+            <a:avLst/>
+          </a:prstGeom>
+        </p:spPr>
+        <p:txBody>
+          <a:bodyPr anchor="t"/>
+          <a:lstStyle/>
+          <a:p>
+            <a:pPr algn="l"/>
+            <a:r>
+              <a:rPr sz="1000">
+                <a:solidFill>
+                  <a:srgbClr val="94A3B8"/>
+                </a:solidFill>
+                <a:latin typeface="+mn-lt"/>
+                <a:cs typeface="+mn-lt"/>
+              </a:rPr>
+              <a:t>Embedded as vector OpenXML chart spaces. Users can edit values, change themes, or modify series formatting natively inside Microsoft PowerPoint.</a:t>
+            </a:r>
+          </a:p>
+        </p:txBody>
+      </p:sp>
+      <p:sp>
+        <p:nvSpPr>
+          <p:cNvPr id="10" name="roundRect 9"/>
+          <p:cNvSpPr/>
+          <p:nvPr/>
+        </p:nvSpPr>
+        <p:spPr>
+          <a:xfrm>
+            <a:off x="7589520" y="4663440"/>
+            <a:ext cx="3657600" cy="1234440"/>
+          </a:xfrm>
+          <a:prstGeom prst="roundRect">
+            <a:avLst/>
+          </a:prstGeom>
+          <a:solidFill>
+            <a:srgbClr val="1E293B"/>
+          </a:solidFill>
+          <a:ln w="13716">
+            <a:solidFill>
+              <a:srgbClr val="6366F1"/>
+            </a:solidFill>
+          </a:ln>
+        </p:spPr>
+        <p:txBody>
+          <a:bodyPr anchor="t"/>
+          <a:lstStyle/>
+          <a:p>
+            <a:pPr algn="l"/>
+            <a:r>
+              <a:rPr b="1" sz="1300">
+                <a:solidFill>
+                  <a:srgbClr val="818CF8"/>
+                </a:solidFill>
+                <a:latin typeface="+mn-lt"/>
+                <a:cs typeface="+mn-lt"/>
+              </a:rPr>
+              <a:t>🎨 Multi-Type Chart Engine</a:t>
+            </a:r>
+          </a:p>
+        </p:txBody>
+      </p:sp>
+      <p:sp>
+        <p:nvSpPr>
+          <p:cNvPr id="11" name="Text Box 10"/>
+          <p:cNvSpPr/>
+          <p:nvPr/>
+        </p:nvSpPr>
+        <p:spPr>
+          <a:xfrm>
+            <a:off x="7772400" y="5074920"/>
+            <a:ext cx="3291840" cy="731520"/>
+          </a:xfrm>
+          <a:prstGeom prst="rect">
+            <a:avLst/>
+          </a:prstGeom>
+        </p:spPr>
+        <p:txBody>
+          <a:bodyPr anchor="t"/>
+          <a:lstStyle/>
+          <a:p>
+            <a:pPr algn="l"/>
+            <a:r>
+              <a:rPr sz="1000">
+                <a:solidFill>
+                  <a:srgbClr val="94A3B8"/>
+                </a:solidFill>
+                <a:latin typeface="+mn-lt"/>
+                <a:cs typeface="+mn-lt"/>
+              </a:rPr>
+              <a:t>Supports column, bar, line, area, and pie chart topologies with custom series coloring, categorical axes, and configurable legend alignments.</a:t>
+            </a:r>
+          </a:p>
+        </p:txBody>
+      </p:sp>
+      <p:sp>
+        <p:nvSpPr>
+          <p:cNvPr id="12" name="Text Box 11"/>
+          <p:cNvSpPr/>
+          <p:nvPr/>
+        </p:nvSpPr>
+        <p:spPr>
+          <a:xfrm>
+            <a:off x="731520" y="6510528"/>
+            <a:ext cx="10725912" cy="228600"/>
+          </a:xfrm>
+          <a:prstGeom prst="rect">
+            <a:avLst/>
+          </a:prstGeom>
+        </p:spPr>
+        <p:txBody>
+          <a:bodyPr anchor="t"/>
+          <a:lstStyle/>
+          <a:p>
+            <a:pPr algn="ctr"/>
+            <a:r>
+              <a:rPr i="1" sz="800">
+                <a:solidFill>
+                  <a:srgbClr val="64748B"/>
+                </a:solidFill>
+                <a:latin typeface="+mn-lt"/>
+                <a:cs typeface="+mn-lt"/>
+              </a:rPr>
+              <a:t>* Disclaimer: All benchmark metrics, performance figures, and simulated architectures in this deck are synthetic demonstration values generated solely to showcase the authoring, formatting, and rendering capabilities of @hokkyss/pptx.</a:t>
+            </a:r>
+          </a:p>
+        </p:txBody>
+      </p:sp>
     </p:spTree>
   </p:cSld>
   <p:clrMapOvr>

</xml_diff>

<commit_message>
feat(media): native audio and video embedding with playback controls and custom poster thumbnails
</commit_message>
<xml_diff>
--- a/hokkyss_showcase_deck.pptx
+++ b/hokkyss_showcase_deck.pptx
@@ -5,7 +5,7 @@
     <p:sldMasterId id="2147483648" r:id="rId1"/>
   </p:sldMasterIdLst>
   <p:notesMasterIdLst>
-    <p:notesMasterId r:id="rId18"/>
+    <p:notesMasterId r:id="rId19"/>
   </p:notesMasterIdLst>
   <p:sldIdLst>
     <p:sldId id="256" r:id="rId2"/>
@@ -24,6 +24,7 @@
     <p:sldId id="269" r:id="rId15"/>
     <p:sldId id="270" r:id="rId16"/>
     <p:sldId id="271" r:id="rId17"/>
+    <p:sldId id="272" r:id="rId18"/>
   </p:sldIdLst>
   <p:sldSz cx="12192000" cy="6858000"/>
   <p:notesSz cx="6858000" cy="9144000"/>
@@ -2277,6 +2278,112 @@
                 <a:latin typeface="+mn-lt"/>
                 <a:cs typeface="+mn-lt"/>
               </a:rPr>
+              <a:t>Multimedia Embedding Keynote: </a:t>
+            </a:r>
+            <a:r>
+              <a:rPr u="sng">
+                <a:latin typeface="+mn-lt"/>
+                <a:cs typeface="+mn-lt"/>
+              </a:rPr>
+              <a:t>Full OpenXML Audio &amp; Video Integration</a:t>
+            </a:r>
+          </a:p>
+          <a:p>
+            <a:pPr algn="l" lvl="0" marL="152400" indent="-152400">
+              <a:buChar char="•"/>
+            </a:pPr>
+            <a:r>
+              <a:rPr>
+                <a:latin typeface="+mn-lt"/>
+                <a:cs typeface="+mn-lt"/>
+              </a:rPr>
+              <a:t>Native PowerPoint speaker/film strip icons rendered with zero client-side dependencies.</a:t>
+            </a:r>
+          </a:p>
+          <a:p>
+            <a:pPr algn="l" lvl="0" marL="152400" indent="-152400">
+              <a:buChar char="•"/>
+            </a:pPr>
+            <a:r>
+              <a:rPr>
+                <a:latin typeface="+mn-lt"/>
+                <a:cs typeface="+mn-lt"/>
+              </a:rPr>
+              <a:t>Full relationship management with dual r:link (media) and r:embed (p14:media) entries.</a:t>
+            </a:r>
+          </a:p>
+          <a:p>
+            <a:pPr algn="l" lvl="0" marL="152400" indent="-152400">
+              <a:buChar char="•"/>
+            </a:pPr>
+            <a:r>
+              <a:rPr>
+                <a:latin typeface="+mn-lt"/>
+                <a:cs typeface="+mn-lt"/>
+              </a:rPr>
+              <a:t>Complete round-trip preservation when parsed and resaved with @hokkyss/pptx-reader.</a:t>
+            </a:r>
+          </a:p>
+        </p:txBody>
+      </p:sp>
+    </p:spTree>
+  </p:cSld>
+  <p:clrMapOvr>
+    <a:masterClrMapping/>
+  </p:clrMapOvr>
+</p:notes>
+</file>
+
+<file path=ppt/notesSlides/notesSlide13.xml><?xml version="1.0" encoding="utf-8"?>
+<p:notes xmlns:a="http://schemas.openxmlformats.org/drawingml/2006/main" xmlns:p="http://schemas.openxmlformats.org/presentationml/2006/main" xmlns:r="http://schemas.openxmlformats.org/officeDocument/2006/relationships">
+  <p:cSld>
+    <p:spTree>
+      <p:nvGrpSpPr>
+        <p:cNvPr id="1" name=""/>
+        <p:cNvGrpSpPr/>
+        <p:nvPr/>
+      </p:nvGrpSpPr>
+      <p:grpSpPr>
+        <a:xfrm>
+          <a:off x="0" y="0"/>
+          <a:ext cx="0" cy="0"/>
+          <a:chOff x="0" y="0"/>
+          <a:chExt cx="0" cy="0"/>
+        </a:xfrm>
+      </p:grpSpPr>
+      <p:sp>
+        <p:nvSpPr>
+          <p:cNvPr id="2" name="Slide Image Placeholder 1"/>
+          <p:cNvSpPr>
+            <a:spLocks noChangeAspect="1" noGrp="1" noRot="1"/>
+          </p:cNvSpPr>
+          <p:nvPr>
+            <p:ph type="sldImg"/>
+          </p:nvPr>
+        </p:nvSpPr>
+        <p:spPr/>
+      </p:sp>
+      <p:sp>
+        <p:nvSpPr>
+          <p:cNvPr id="3" name="Notes Placeholder 2"/>
+          <p:cNvSpPr>
+            <a:spLocks noGrp="1"/>
+          </p:cNvSpPr>
+          <p:nvPr>
+            <p:ph idx="1" type="body"/>
+          </p:nvPr>
+        </p:nvSpPr>
+        <p:spPr/>
+        <p:txBody>
+          <a:bodyPr anchor="t"/>
+          <a:lstStyle/>
+          <a:p>
+            <a:pPr algn="l" lvl="0"/>
+            <a:r>
+              <a:rPr b="1">
+                <a:latin typeface="+mn-lt"/>
+                <a:cs typeface="+mn-lt"/>
+              </a:rPr>
               <a:t>Empirical Benchmark Keynote: </a:t>
             </a:r>
             <a:r>
@@ -6192,7 +6299,7 @@
       <p:sp>
         <p:nvSpPr>
           <p:cNvPr id="10" name="roundRect 9">
-            <a:hlinkClick r:id="rId5" tooltip="Jump directly to Slide 16" action="ppaction://hlinksldjump"/>
+            <a:hlinkClick r:id="rId5" tooltip="Jump directly to Slide 17" action="ppaction://hlinksldjump"/>
           </p:cNvPr>
           <p:cNvSpPr/>
           <p:nvPr/>
@@ -6227,7 +6334,7 @@
                 <a:latin typeface="+mn-lt"/>
                 <a:cs typeface="+mn-lt"/>
               </a:rPr>
-              <a:t>⚡ Slide 16: Engine Benchmark Matrix ➔</a:t>
+              <a:t>⚡ Slide 17: Engine Benchmark Matrix ➔</a:t>
             </a:r>
           </a:p>
           <a:p>
@@ -6875,7 +6982,7 @@
       <p:sp>
         <p:nvSpPr>
           <p:cNvPr id="5" name="roundRect 4">
-            <a:hlinkClick r:id="rId3" tooltip="Advance to Live Benchmarks (Slide 16)" action="ppaction://hlinksldjump"/>
+            <a:hlinkClick r:id="rId3" tooltip="Advance to Multimedia (Slide 16)" action="ppaction://hlinksldjump"/>
           </p:cNvPr>
           <p:cNvSpPr/>
           <p:nvPr/>
@@ -6925,7 +7032,7 @@
                 <a:latin typeface="+mn-lt"/>
                 <a:cs typeface="+mn-lt"/>
               </a:rPr>
-              <a:t>Benchmarks ➔</a:t>
+              <a:t>Multimedia ➔</a:t>
             </a:r>
           </a:p>
         </p:txBody>
@@ -7588,6 +7695,1118 @@
 </file>
 
 <file path=ppt/slides/slide16.xml><?xml version="1.0" encoding="utf-8"?>
+<p:sld xmlns:a="http://schemas.openxmlformats.org/drawingml/2006/main" xmlns:p="http://schemas.openxmlformats.org/presentationml/2006/main" xmlns:r="http://schemas.openxmlformats.org/officeDocument/2006/relationships">
+  <p:cSld>
+    <p:bg>
+      <p:bgPr>
+        <a:solidFill>
+          <a:srgbClr val="F8FAFC"/>
+        </a:solidFill>
+        <a:effectLst/>
+      </p:bgPr>
+    </p:bg>
+    <p:spTree>
+      <p:nvGrpSpPr>
+        <p:cNvPr id="1" name=""/>
+        <p:cNvGrpSpPr/>
+        <p:nvPr/>
+      </p:nvGrpSpPr>
+      <p:grpSpPr>
+        <a:xfrm>
+          <a:off x="0" y="0"/>
+          <a:ext cx="0" cy="0"/>
+          <a:chOff x="0" y="0"/>
+          <a:chExt cx="0" cy="0"/>
+        </a:xfrm>
+      </p:grpSpPr>
+      <p:sp>
+        <p:nvSpPr>
+          <p:cNvPr id="2" name="Text Box 1"/>
+          <p:cNvSpPr txBox="1"/>
+          <p:nvPr/>
+        </p:nvSpPr>
+        <p:spPr>
+          <a:xfrm>
+            <a:off x="731520" y="731520"/>
+            <a:ext cx="10725912" cy="548640"/>
+          </a:xfrm>
+          <a:prstGeom prst="rect">
+            <a:avLst/>
+          </a:prstGeom>
+        </p:spPr>
+        <p:txBody>
+          <a:bodyPr anchor="t"/>
+          <a:lstStyle/>
+          <a:p>
+            <a:pPr algn="l"/>
+            <a:r>
+              <a:rPr b="1" sz="2400">
+                <a:solidFill>
+                  <a:srgbClr val="0F172A"/>
+                </a:solidFill>
+                <a:latin typeface="+mj-lt"/>
+                <a:cs typeface="+mj-lt"/>
+              </a:rPr>
+              <a:t>Native Audio &amp; Video Media Embedding Engine</a:t>
+            </a:r>
+          </a:p>
+        </p:txBody>
+      </p:sp>
+      <p:sp>
+        <p:nvSpPr>
+          <p:cNvPr id="3" name="Text Box 2"/>
+          <p:cNvSpPr txBox="1"/>
+          <p:nvPr/>
+        </p:nvSpPr>
+        <p:spPr>
+          <a:xfrm>
+            <a:off x="731520" y="1280160"/>
+            <a:ext cx="10725912" cy="365760"/>
+          </a:xfrm>
+          <a:prstGeom prst="rect">
+            <a:avLst/>
+          </a:prstGeom>
+        </p:spPr>
+        <p:txBody>
+          <a:bodyPr anchor="t"/>
+          <a:lstStyle/>
+          <a:p>
+            <a:pPr algn="l"/>
+            <a:r>
+              <a:rPr sz="1400">
+                <a:solidFill>
+                  <a:srgbClr val="64748B"/>
+                </a:solidFill>
+                <a:latin typeface="+mn-lt"/>
+                <a:cs typeface="+mn-lt"/>
+              </a:rPr>
+              <a:t>OpenXML DrawingML &lt;p:pic&gt; multimedia integration with automatic relationship linking, playback triggers &amp; timing</a:t>
+            </a:r>
+          </a:p>
+        </p:txBody>
+      </p:sp>
+      <p:sp>
+        <p:nvSpPr>
+          <p:cNvPr id="4" name="roundRect 3">
+            <a:hlinkClick r:id="rId2" tooltip="Return to Hyperlinks Hub (Slide 14)" action="ppaction://hlinksldjump"/>
+          </p:cNvPr>
+          <p:cNvSpPr/>
+          <p:nvPr/>
+        </p:nvSpPr>
+        <p:spPr>
+          <a:xfrm>
+            <a:off x="7315200" y="731520"/>
+            <a:ext cx="2011680" cy="411480"/>
+          </a:xfrm>
+          <a:prstGeom prst="roundRect">
+            <a:avLst/>
+          </a:prstGeom>
+          <a:solidFill>
+            <a:srgbClr val="0284C7"/>
+          </a:solidFill>
+          <a:ln w="13716">
+            <a:solidFill>
+              <a:srgbClr val="38BDF8"/>
+            </a:solidFill>
+          </a:ln>
+          <a:effectLst>
+            <a:outerShdw blurRad="109728" dist="38100" dir="5400000">
+              <a:srgbClr val="0284C7">
+                <a:alpha val="30000"/>
+              </a:srgbClr>
+            </a:outerShdw>
+          </a:effectLst>
+        </p:spPr>
+        <p:txBody>
+          <a:bodyPr anchor="t"/>
+          <a:lstStyle/>
+          <a:p>
+            <a:pPr algn="ctr"/>
+            <a:r>
+              <a:rPr b="1" sz="1000">
+                <a:solidFill>
+                  <a:srgbClr val="FFFFFF"/>
+                </a:solidFill>
+                <a:latin typeface="+mn-lt"/>
+                <a:cs typeface="+mn-lt"/>
+              </a:rPr>
+              <a:t>⬅ Back to Nav Hub</a:t>
+            </a:r>
+          </a:p>
+        </p:txBody>
+      </p:sp>
+      <p:sp>
+        <p:nvSpPr>
+          <p:cNvPr id="5" name="roundRect 4">
+            <a:hlinkClick r:id="rId3" tooltip="Advance to Live Benchmarks (Slide 17)" action="ppaction://hlinksldjump"/>
+          </p:cNvPr>
+          <p:cNvSpPr/>
+          <p:nvPr/>
+        </p:nvSpPr>
+        <p:spPr>
+          <a:xfrm>
+            <a:off x="9509760" y="731520"/>
+            <a:ext cx="1828800" cy="411480"/>
+          </a:xfrm>
+          <a:prstGeom prst="roundRect">
+            <a:avLst/>
+          </a:prstGeom>
+          <a:gradFill>
+            <a:gsLst>
+              <a:gs pos="0">
+                <a:srgbClr val="10B981"/>
+              </a:gs>
+              <a:gs pos="100000">
+                <a:srgbClr val="059669"/>
+              </a:gs>
+            </a:gsLst>
+            <a:lin ang="5400000" scaled="1"/>
+          </a:gradFill>
+          <a:ln w="13716">
+            <a:solidFill>
+              <a:srgbClr val="34D399"/>
+            </a:solidFill>
+          </a:ln>
+          <a:effectLst>
+            <a:outerShdw blurRad="109728" dist="38100" dir="5400000">
+              <a:srgbClr val="10B981">
+                <a:alpha val="30000"/>
+              </a:srgbClr>
+            </a:outerShdw>
+          </a:effectLst>
+        </p:spPr>
+        <p:txBody>
+          <a:bodyPr anchor="t"/>
+          <a:lstStyle/>
+          <a:p>
+            <a:pPr algn="ctr"/>
+            <a:r>
+              <a:rPr b="1" sz="1000">
+                <a:solidFill>
+                  <a:srgbClr val="FFFFFF"/>
+                </a:solidFill>
+                <a:latin typeface="+mn-lt"/>
+                <a:cs typeface="+mn-lt"/>
+              </a:rPr>
+              <a:t>Benchmarks ➔</a:t>
+            </a:r>
+          </a:p>
+        </p:txBody>
+      </p:sp>
+      <p:sp>
+        <p:nvSpPr>
+          <p:cNvPr id="6" name="roundRect 5"/>
+          <p:cNvSpPr/>
+          <p:nvPr/>
+        </p:nvSpPr>
+        <p:spPr>
+          <a:xfrm>
+            <a:off x="731520" y="1828800"/>
+            <a:ext cx="5212080" cy="4480560"/>
+          </a:xfrm>
+          <a:prstGeom prst="roundRect">
+            <a:avLst/>
+          </a:prstGeom>
+          <a:solidFill>
+            <a:srgbClr val="FFFFFF"/>
+          </a:solidFill>
+          <a:ln w="13716">
+            <a:solidFill>
+              <a:srgbClr val="E2E8F0"/>
+            </a:solidFill>
+          </a:ln>
+          <a:effectLst>
+            <a:outerShdw blurRad="109728" dist="38100" dir="5400000">
+              <a:srgbClr val="0F172A">
+                <a:alpha val="8000"/>
+              </a:srgbClr>
+            </a:outerShdw>
+          </a:effectLst>
+        </p:spPr>
+        <p:txBody>
+          <a:bodyPr/>
+          <a:lstStyle/>
+          <a:p>
+            <a:endParaRPr/>
+          </a:p>
+        </p:txBody>
+      </p:sp>
+      <p:sp>
+        <p:nvSpPr>
+          <p:cNvPr id="7" name="Text Box 6"/>
+          <p:cNvSpPr txBox="1"/>
+          <p:nvPr/>
+        </p:nvSpPr>
+        <p:spPr>
+          <a:xfrm>
+            <a:off x="914400" y="2011680"/>
+            <a:ext cx="4846320" cy="320040"/>
+          </a:xfrm>
+          <a:prstGeom prst="rect">
+            <a:avLst/>
+          </a:prstGeom>
+        </p:spPr>
+        <p:txBody>
+          <a:bodyPr anchor="t"/>
+          <a:lstStyle/>
+          <a:p>
+            <a:pPr algn="l"/>
+            <a:r>
+              <a:rPr b="1" sz="1300">
+                <a:solidFill>
+                  <a:srgbClr val="0F172A"/>
+                </a:solidFill>
+                <a:latin typeface="+mn-lt"/>
+                <a:cs typeface="+mn-lt"/>
+              </a:rPr>
+              <a:t>🔊 Embedded Audio &amp; Narration Tracks</a:t>
+            </a:r>
+          </a:p>
+        </p:txBody>
+      </p:sp>
+      <p:sp>
+        <p:nvSpPr>
+          <p:cNvPr id="8" name="Text Box 7"/>
+          <p:cNvSpPr txBox="1"/>
+          <p:nvPr/>
+        </p:nvSpPr>
+        <p:spPr>
+          <a:xfrm>
+            <a:off x="914400" y="2331720"/>
+            <a:ext cx="4846320" cy="411480"/>
+          </a:xfrm>
+          <a:prstGeom prst="rect">
+            <a:avLst/>
+          </a:prstGeom>
+        </p:spPr>
+        <p:txBody>
+          <a:bodyPr anchor="t"/>
+          <a:lstStyle/>
+          <a:p>
+            <a:pPr algn="l"/>
+            <a:r>
+              <a:rPr sz="1050">
+                <a:solidFill>
+                  <a:srgbClr val="64748B"/>
+                </a:solidFill>
+                <a:latin typeface="+mn-lt"/>
+                <a:cs typeface="+mn-lt"/>
+              </a:rPr>
+              <a:t>Native speaker icon rendered automatically with interactive click-to-play &amp; automatic slide load triggers:</a:t>
+            </a:r>
+          </a:p>
+        </p:txBody>
+      </p:sp>
+      <p:sp>
+        <p:nvSpPr>
+          <p:cNvPr id="9" name="roundRect 8"/>
+          <p:cNvSpPr/>
+          <p:nvPr/>
+        </p:nvSpPr>
+        <p:spPr>
+          <a:xfrm>
+            <a:off x="914400" y="2788920"/>
+            <a:ext cx="4846320" cy="1371600"/>
+          </a:xfrm>
+          <a:prstGeom prst="roundRect">
+            <a:avLst/>
+          </a:prstGeom>
+          <a:solidFill>
+            <a:srgbClr val="F1F5F9"/>
+          </a:solidFill>
+          <a:ln w="13716">
+            <a:solidFill>
+              <a:srgbClr val="CBD5E1"/>
+            </a:solidFill>
+          </a:ln>
+        </p:spPr>
+        <p:txBody>
+          <a:bodyPr/>
+          <a:lstStyle/>
+          <a:p>
+            <a:endParaRPr/>
+          </a:p>
+        </p:txBody>
+      </p:sp>
+      <p:pic>
+        <p:nvPicPr>
+          <p:cNvPr id="10" name="Showcase Audio Track"/>
+          <p:cNvPicPr>
+            <a:picLocks noChangeAspect="1"/>
+          </p:cNvPicPr>
+          <p:nvPr>
+            <a:audioFile r:link="rId5"/>
+            <p:extLst>
+              <p:ext uri="{DAA4B4D4-6D71-4841-9C94-3DE7FCFB9230}">
+                <p14:media xmlns:p14="http://schemas.microsoft.com/office/powerpoint/2010/main" r:embed="rId6"/>
+              </p:ext>
+            </p:extLst>
+          </p:nvPr>
+        </p:nvPicPr>
+        <p:blipFill>
+          <a:blip r:embed="rId4"/>
+          <a:stretch>
+            <a:fillRect/>
+          </a:stretch>
+        </p:blipFill>
+        <p:spPr>
+          <a:xfrm>
+            <a:off x="1097280" y="3017520"/>
+            <a:ext cx="914400" cy="914400"/>
+          </a:xfrm>
+          <a:prstGeom prst="rect">
+            <a:avLst/>
+          </a:prstGeom>
+          <a:noFill/>
+          <a:ln>
+            <a:noFill/>
+          </a:ln>
+        </p:spPr>
+      </p:pic>
+      <p:sp>
+        <p:nvSpPr>
+          <p:cNvPr id="11" name="Text Box 10"/>
+          <p:cNvSpPr txBox="1"/>
+          <p:nvPr/>
+        </p:nvSpPr>
+        <p:spPr>
+          <a:xfrm>
+            <a:off x="2103120" y="2926080"/>
+            <a:ext cx="3566160" cy="1097280"/>
+          </a:xfrm>
+          <a:prstGeom prst="rect">
+            <a:avLst/>
+          </a:prstGeom>
+        </p:spPr>
+        <p:txBody>
+          <a:bodyPr anchor="t"/>
+          <a:lstStyle/>
+          <a:p>
+            <a:pPr algn="l"/>
+            <a:r>
+              <a:rPr b="1" sz="1100">
+                <a:solidFill>
+                  <a:srgbClr val="0F172A"/>
+                </a:solidFill>
+                <a:latin typeface="+mn-lt"/>
+                <a:cs typeface="+mn-lt"/>
+              </a:rPr>
+              <a:t>Interactive Audio Clip (Click custom cover in slideshow)</a:t>
+            </a:r>
+          </a:p>
+          <a:p>
+            <a:pPr algn="l"/>
+            <a:r>
+              <a:rPr sz="950">
+                <a:solidFill>
+                  <a:srgbClr val="0284C7"/>
+                </a:solidFill>
+                <a:latin typeface="+mn-lt"/>
+                <a:cs typeface="+mn-lt"/>
+              </a:rPr>
+              <a:t>• Source: assets/sample-audio.mp3</a:t>
+            </a:r>
+          </a:p>
+          <a:p>
+            <a:pPr algn="l"/>
+            <a:r>
+              <a:rPr sz="950">
+                <a:solidFill>
+                  <a:srgbClr val="64748B"/>
+                </a:solidFill>
+                <a:latin typeface="+mn-lt"/>
+                <a:cs typeface="+mn-lt"/>
+              </a:rPr>
+              <a:t>• Poster: custom-audio-thumbnail.png (Album art)</a:t>
+            </a:r>
+          </a:p>
+          <a:p>
+            <a:pPr algn="l"/>
+            <a:r>
+              <a:rPr sz="950">
+                <a:solidFill>
+                  <a:srgbClr val="64748B"/>
+                </a:solidFill>
+                <a:latin typeface="+mn-lt"/>
+                <a:cs typeface="+mn-lt"/>
+              </a:rPr>
+              <a:t>• Trigger: onClick | Loop: true | Vol: 80%</a:t>
+            </a:r>
+          </a:p>
+        </p:txBody>
+      </p:sp>
+      <p:sp>
+        <p:nvSpPr>
+          <p:cNvPr id="12" name="roundRect 11"/>
+          <p:cNvSpPr/>
+          <p:nvPr/>
+        </p:nvSpPr>
+        <p:spPr>
+          <a:xfrm>
+            <a:off x="914400" y="4343400"/>
+            <a:ext cx="4846320" cy="1737360"/>
+          </a:xfrm>
+          <a:prstGeom prst="roundRect">
+            <a:avLst/>
+          </a:prstGeom>
+          <a:solidFill>
+            <a:srgbClr val="0F172A"/>
+          </a:solidFill>
+        </p:spPr>
+        <p:txBody>
+          <a:bodyPr/>
+          <a:lstStyle/>
+          <a:p>
+            <a:endParaRPr/>
+          </a:p>
+        </p:txBody>
+      </p:sp>
+      <p:sp>
+        <p:nvSpPr>
+          <p:cNvPr id="13" name="Text Box 12"/>
+          <p:cNvSpPr txBox="1"/>
+          <p:nvPr/>
+        </p:nvSpPr>
+        <p:spPr>
+          <a:xfrm>
+            <a:off x="1005840" y="4389120"/>
+            <a:ext cx="4663440" cy="1645920"/>
+          </a:xfrm>
+          <a:prstGeom prst="rect">
+            <a:avLst/>
+          </a:prstGeom>
+        </p:spPr>
+        <p:txBody>
+          <a:bodyPr anchor="t"/>
+          <a:lstStyle/>
+          <a:p>
+            <a:pPr algn="l"/>
+            <a:r>
+              <a:rPr b="1" sz="900">
+                <a:solidFill>
+                  <a:srgbClr val="38BDF8"/>
+                </a:solidFill>
+                <a:latin typeface="+mn-lt"/>
+                <a:cs typeface="+mn-lt"/>
+              </a:rPr>
+              <a:t>// Embed audio with custom album artwork poster</a:t>
+            </a:r>
+          </a:p>
+          <a:p>
+            <a:pPr algn="l"/>
+            <a:r>
+              <a:rPr sz="850">
+                <a:solidFill>
+                  <a:srgbClr val="E2E8F0"/>
+                </a:solidFill>
+                <a:latin typeface="+mn-lt"/>
+                <a:cs typeface="+mn-lt"/>
+              </a:rPr>
+              <a:t>slide.addAudio(audioBuffer, {</a:t>
+            </a:r>
+          </a:p>
+          <a:p>
+            <a:pPr algn="l"/>
+            <a:r>
+              <a:rPr sz="850">
+                <a:solidFill>
+                  <a:srgbClr val="E2E8F0"/>
+                </a:solidFill>
+                <a:latin typeface="+mn-lt"/>
+                <a:cs typeface="+mn-lt"/>
+              </a:rPr>
+              <a:t>  fileName: 'sample-audio.mp3',</a:t>
+            </a:r>
+          </a:p>
+          <a:p>
+            <a:pPr algn="l"/>
+            <a:r>
+              <a:rPr sz="850">
+                <a:solidFill>
+                  <a:srgbClr val="E2E8F0"/>
+                </a:solidFill>
+                <a:latin typeface="+mn-lt"/>
+                <a:cs typeface="+mn-lt"/>
+              </a:rPr>
+              <a:t>  mimeType: 'audio/mpeg',</a:t>
+            </a:r>
+          </a:p>
+          <a:p>
+            <a:pPr algn="l"/>
+            <a:r>
+              <a:rPr sz="850">
+                <a:solidFill>
+                  <a:srgbClr val="E2E8F0"/>
+                </a:solidFill>
+                <a:latin typeface="+mn-lt"/>
+                <a:cs typeface="+mn-lt"/>
+              </a:rPr>
+              <a:t>  poster: { data: albumArtBytes, mimeType: 'image/png' },</a:t>
+            </a:r>
+          </a:p>
+          <a:p>
+            <a:pPr algn="l"/>
+            <a:r>
+              <a:rPr sz="850">
+                <a:solidFill>
+                  <a:srgbClr val="E2E8F0"/>
+                </a:solidFill>
+                <a:latin typeface="+mn-lt"/>
+                <a:cs typeface="+mn-lt"/>
+              </a:rPr>
+              <a:t>  trigger: 'onClick', // or 'automatic'</a:t>
+            </a:r>
+          </a:p>
+          <a:p>
+            <a:pPr algn="l"/>
+            <a:r>
+              <a:rPr sz="850">
+                <a:solidFill>
+                  <a:srgbClr val="E2E8F0"/>
+                </a:solidFill>
+                <a:latin typeface="+mn-lt"/>
+                <a:cs typeface="+mn-lt"/>
+              </a:rPr>
+              <a:t>  loop: true,</a:t>
+            </a:r>
+          </a:p>
+          <a:p>
+            <a:pPr algn="l"/>
+            <a:r>
+              <a:rPr sz="850">
+                <a:solidFill>
+                  <a:srgbClr val="E2E8F0"/>
+                </a:solidFill>
+                <a:latin typeface="+mn-lt"/>
+                <a:cs typeface="+mn-lt"/>
+              </a:rPr>
+              <a:t>  volume: 0.8</a:t>
+            </a:r>
+          </a:p>
+          <a:p>
+            <a:pPr algn="l"/>
+            <a:r>
+              <a:rPr sz="850">
+                <a:solidFill>
+                  <a:srgbClr val="E2E8F0"/>
+                </a:solidFill>
+                <a:latin typeface="+mn-lt"/>
+                <a:cs typeface="+mn-lt"/>
+              </a:rPr>
+              <a:t>});</a:t>
+            </a:r>
+          </a:p>
+        </p:txBody>
+      </p:sp>
+      <p:sp>
+        <p:nvSpPr>
+          <p:cNvPr id="14" name="roundRect 13"/>
+          <p:cNvSpPr/>
+          <p:nvPr/>
+        </p:nvSpPr>
+        <p:spPr>
+          <a:xfrm>
+            <a:off x="6217920" y="1828800"/>
+            <a:ext cx="5212080" cy="4480560"/>
+          </a:xfrm>
+          <a:prstGeom prst="roundRect">
+            <a:avLst/>
+          </a:prstGeom>
+          <a:solidFill>
+            <a:srgbClr val="FFFFFF"/>
+          </a:solidFill>
+          <a:ln w="13716">
+            <a:solidFill>
+              <a:srgbClr val="E2E8F0"/>
+            </a:solidFill>
+          </a:ln>
+          <a:effectLst>
+            <a:outerShdw blurRad="109728" dist="38100" dir="5400000">
+              <a:srgbClr val="0F172A">
+                <a:alpha val="8000"/>
+              </a:srgbClr>
+            </a:outerShdw>
+          </a:effectLst>
+        </p:spPr>
+        <p:txBody>
+          <a:bodyPr/>
+          <a:lstStyle/>
+          <a:p>
+            <a:endParaRPr/>
+          </a:p>
+        </p:txBody>
+      </p:sp>
+      <p:sp>
+        <p:nvSpPr>
+          <p:cNvPr id="15" name="Text Box 14"/>
+          <p:cNvSpPr txBox="1"/>
+          <p:nvPr/>
+        </p:nvSpPr>
+        <p:spPr>
+          <a:xfrm>
+            <a:off x="6400800" y="2011680"/>
+            <a:ext cx="4846320" cy="320040"/>
+          </a:xfrm>
+          <a:prstGeom prst="rect">
+            <a:avLst/>
+          </a:prstGeom>
+        </p:spPr>
+        <p:txBody>
+          <a:bodyPr anchor="t"/>
+          <a:lstStyle/>
+          <a:p>
+            <a:pPr algn="l"/>
+            <a:r>
+              <a:rPr b="1" sz="1300">
+                <a:solidFill>
+                  <a:srgbClr val="0F172A"/>
+                </a:solidFill>
+                <a:latin typeface="+mn-lt"/>
+                <a:cs typeface="+mn-lt"/>
+              </a:rPr>
+              <a:t>🎬 High-Fidelity Video &amp; Motion Graphics</a:t>
+            </a:r>
+          </a:p>
+        </p:txBody>
+      </p:sp>
+      <p:sp>
+        <p:nvSpPr>
+          <p:cNvPr id="16" name="Text Box 15"/>
+          <p:cNvSpPr txBox="1"/>
+          <p:nvPr/>
+        </p:nvSpPr>
+        <p:spPr>
+          <a:xfrm>
+            <a:off x="6400800" y="2331720"/>
+            <a:ext cx="4846320" cy="411480"/>
+          </a:xfrm>
+          <a:prstGeom prst="rect">
+            <a:avLst/>
+          </a:prstGeom>
+        </p:spPr>
+        <p:txBody>
+          <a:bodyPr anchor="t"/>
+          <a:lstStyle/>
+          <a:p>
+            <a:pPr algn="l"/>
+            <a:r>
+              <a:rPr sz="1050">
+                <a:solidFill>
+                  <a:srgbClr val="64748B"/>
+                </a:solidFill>
+                <a:latin typeface="+mn-lt"/>
+                <a:cs typeface="+mn-lt"/>
+              </a:rPr>
+              <a:t>Embed cross-platform MP4/MOV/AVI video containers with custom poster thumbnails, looping, and mute:</a:t>
+            </a:r>
+          </a:p>
+        </p:txBody>
+      </p:sp>
+      <p:sp>
+        <p:nvSpPr>
+          <p:cNvPr id="17" name="roundRect 16"/>
+          <p:cNvSpPr/>
+          <p:nvPr/>
+        </p:nvSpPr>
+        <p:spPr>
+          <a:xfrm>
+            <a:off x="6400800" y="2788920"/>
+            <a:ext cx="4846320" cy="1371600"/>
+          </a:xfrm>
+          <a:prstGeom prst="roundRect">
+            <a:avLst/>
+          </a:prstGeom>
+          <a:solidFill>
+            <a:srgbClr val="0F172A"/>
+          </a:solidFill>
+          <a:ln w="13716">
+            <a:solidFill>
+              <a:srgbClr val="334155"/>
+            </a:solidFill>
+          </a:ln>
+        </p:spPr>
+        <p:txBody>
+          <a:bodyPr/>
+          <a:lstStyle/>
+          <a:p>
+            <a:endParaRPr/>
+          </a:p>
+        </p:txBody>
+      </p:sp>
+      <p:pic>
+        <p:nvPicPr>
+          <p:cNvPr id="18" name="Showcase Video Track"/>
+          <p:cNvPicPr>
+            <a:picLocks noChangeAspect="1"/>
+          </p:cNvPicPr>
+          <p:nvPr>
+            <a:videoFile r:link="rId8"/>
+            <p:extLst>
+              <p:ext uri="{DAA4B4D4-6D71-4841-9C94-3DE7FCFB9230}">
+                <p14:media xmlns:p14="http://schemas.microsoft.com/office/powerpoint/2010/main" r:embed="rId9"/>
+              </p:ext>
+            </p:extLst>
+          </p:nvPr>
+        </p:nvPicPr>
+        <p:blipFill>
+          <a:blip r:embed="rId7"/>
+          <a:stretch>
+            <a:fillRect/>
+          </a:stretch>
+        </p:blipFill>
+        <p:spPr>
+          <a:xfrm>
+            <a:off x="6537960" y="2880360"/>
+            <a:ext cx="1645920" cy="1188720"/>
+          </a:xfrm>
+          <a:prstGeom prst="rect">
+            <a:avLst/>
+          </a:prstGeom>
+          <a:noFill/>
+          <a:ln>
+            <a:noFill/>
+          </a:ln>
+        </p:spPr>
+      </p:pic>
+      <p:sp>
+        <p:nvSpPr>
+          <p:cNvPr id="19" name="Text Box 18"/>
+          <p:cNvSpPr txBox="1"/>
+          <p:nvPr/>
+        </p:nvSpPr>
+        <p:spPr>
+          <a:xfrm>
+            <a:off x="8321040" y="2926080"/>
+            <a:ext cx="2834640" cy="1097280"/>
+          </a:xfrm>
+          <a:prstGeom prst="rect">
+            <a:avLst/>
+          </a:prstGeom>
+        </p:spPr>
+        <p:txBody>
+          <a:bodyPr anchor="t"/>
+          <a:lstStyle/>
+          <a:p>
+            <a:pPr algn="l"/>
+            <a:r>
+              <a:rPr b="1" sz="1100">
+                <a:solidFill>
+                  <a:srgbClr val="FFFFFF"/>
+                </a:solidFill>
+                <a:latin typeface="+mn-lt"/>
+                <a:cs typeface="+mn-lt"/>
+              </a:rPr>
+              <a:t>Embedded Video Player Container</a:t>
+            </a:r>
+          </a:p>
+          <a:p>
+            <a:pPr algn="l"/>
+            <a:r>
+              <a:rPr sz="950">
+                <a:solidFill>
+                  <a:srgbClr val="38BDF8"/>
+                </a:solidFill>
+                <a:latin typeface="+mn-lt"/>
+                <a:cs typeface="+mn-lt"/>
+              </a:rPr>
+              <a:t>• Source: assets/sample-video.mp4 (H.264)</a:t>
+            </a:r>
+          </a:p>
+          <a:p>
+            <a:pPr algn="l"/>
+            <a:r>
+              <a:rPr sz="950">
+                <a:solidFill>
+                  <a:srgbClr val="94A3B8"/>
+                </a:solidFill>
+                <a:latin typeface="+mn-lt"/>
+                <a:cs typeface="+mn-lt"/>
+              </a:rPr>
+              <a:t>• Poster: custom-video-thumbnail.png (Cinematic 4K)</a:t>
+            </a:r>
+          </a:p>
+          <a:p>
+            <a:pPr algn="l"/>
+            <a:r>
+              <a:rPr sz="950">
+                <a:solidFill>
+                  <a:srgbClr val="94A3B8"/>
+                </a:solidFill>
+                <a:latin typeface="+mn-lt"/>
+                <a:cs typeface="+mn-lt"/>
+              </a:rPr>
+              <a:t>• Trigger: automatic | Muted: true</a:t>
+            </a:r>
+          </a:p>
+        </p:txBody>
+      </p:sp>
+      <p:sp>
+        <p:nvSpPr>
+          <p:cNvPr id="20" name="roundRect 19"/>
+          <p:cNvSpPr/>
+          <p:nvPr/>
+        </p:nvSpPr>
+        <p:spPr>
+          <a:xfrm>
+            <a:off x="6400800" y="4343400"/>
+            <a:ext cx="4846320" cy="1737360"/>
+          </a:xfrm>
+          <a:prstGeom prst="roundRect">
+            <a:avLst/>
+          </a:prstGeom>
+          <a:solidFill>
+            <a:srgbClr val="0F172A"/>
+          </a:solidFill>
+        </p:spPr>
+        <p:txBody>
+          <a:bodyPr/>
+          <a:lstStyle/>
+          <a:p>
+            <a:endParaRPr/>
+          </a:p>
+        </p:txBody>
+      </p:sp>
+      <p:sp>
+        <p:nvSpPr>
+          <p:cNvPr id="21" name="Text Box 20"/>
+          <p:cNvSpPr txBox="1"/>
+          <p:nvPr/>
+        </p:nvSpPr>
+        <p:spPr>
+          <a:xfrm>
+            <a:off x="6492240" y="4389120"/>
+            <a:ext cx="4663440" cy="1645920"/>
+          </a:xfrm>
+          <a:prstGeom prst="rect">
+            <a:avLst/>
+          </a:prstGeom>
+        </p:spPr>
+        <p:txBody>
+          <a:bodyPr anchor="t"/>
+          <a:lstStyle/>
+          <a:p>
+            <a:pPr algn="l"/>
+            <a:r>
+              <a:rPr b="1" sz="900">
+                <a:solidFill>
+                  <a:srgbClr val="38BDF8"/>
+                </a:solidFill>
+                <a:latin typeface="+mn-lt"/>
+                <a:cs typeface="+mn-lt"/>
+              </a:rPr>
+              <a:t>// Embed video with custom poster thumbnail &amp; controls</a:t>
+            </a:r>
+          </a:p>
+          <a:p>
+            <a:pPr algn="l"/>
+            <a:r>
+              <a:rPr sz="850">
+                <a:solidFill>
+                  <a:srgbClr val="E2E8F0"/>
+                </a:solidFill>
+                <a:latin typeface="+mn-lt"/>
+                <a:cs typeface="+mn-lt"/>
+              </a:rPr>
+              <a:t>slide.addVideo(videoBuffer, {</a:t>
+            </a:r>
+          </a:p>
+          <a:p>
+            <a:pPr algn="l"/>
+            <a:r>
+              <a:rPr sz="850">
+                <a:solidFill>
+                  <a:srgbClr val="E2E8F0"/>
+                </a:solidFill>
+                <a:latin typeface="+mn-lt"/>
+                <a:cs typeface="+mn-lt"/>
+              </a:rPr>
+              <a:t>  fileName: 'product_demo.mp4',</a:t>
+            </a:r>
+          </a:p>
+          <a:p>
+            <a:pPr algn="l"/>
+            <a:r>
+              <a:rPr sz="850">
+                <a:solidFill>
+                  <a:srgbClr val="E2E8F0"/>
+                </a:solidFill>
+                <a:latin typeface="+mn-lt"/>
+                <a:cs typeface="+mn-lt"/>
+              </a:rPr>
+              <a:t>  mimeType: 'video/mp4',</a:t>
+            </a:r>
+          </a:p>
+          <a:p>
+            <a:pPr algn="l"/>
+            <a:r>
+              <a:rPr sz="850">
+                <a:solidFill>
+                  <a:srgbClr val="E2E8F0"/>
+                </a:solidFill>
+                <a:latin typeface="+mn-lt"/>
+                <a:cs typeface="+mn-lt"/>
+              </a:rPr>
+              <a:t>  poster: { data: posterBytes, mimeType: 'image/png' },</a:t>
+            </a:r>
+          </a:p>
+          <a:p>
+            <a:pPr algn="l"/>
+            <a:r>
+              <a:rPr sz="850">
+                <a:solidFill>
+                  <a:srgbClr val="E2E8F0"/>
+                </a:solidFill>
+                <a:latin typeface="+mn-lt"/>
+                <a:cs typeface="+mn-lt"/>
+              </a:rPr>
+              <a:t>  x: inches(2), y: inches(1.5),</a:t>
+            </a:r>
+          </a:p>
+          <a:p>
+            <a:pPr algn="l"/>
+            <a:r>
+              <a:rPr sz="850">
+                <a:solidFill>
+                  <a:srgbClr val="E2E8F0"/>
+                </a:solidFill>
+                <a:latin typeface="+mn-lt"/>
+                <a:cs typeface="+mn-lt"/>
+              </a:rPr>
+              <a:t>  w: inches(6), h: inches(4.5),</a:t>
+            </a:r>
+          </a:p>
+          <a:p>
+            <a:pPr algn="l"/>
+            <a:r>
+              <a:rPr sz="850">
+                <a:solidFill>
+                  <a:srgbClr val="E2E8F0"/>
+                </a:solidFill>
+                <a:latin typeface="+mn-lt"/>
+                <a:cs typeface="+mn-lt"/>
+              </a:rPr>
+              <a:t>  muted: true, loop: true</a:t>
+            </a:r>
+          </a:p>
+          <a:p>
+            <a:pPr algn="l"/>
+            <a:r>
+              <a:rPr sz="850">
+                <a:solidFill>
+                  <a:srgbClr val="E2E8F0"/>
+                </a:solidFill>
+                <a:latin typeface="+mn-lt"/>
+                <a:cs typeface="+mn-lt"/>
+              </a:rPr>
+              <a:t>});</a:t>
+            </a:r>
+          </a:p>
+        </p:txBody>
+      </p:sp>
+      <p:sp>
+        <p:nvSpPr>
+          <p:cNvPr id="22" name="Text Box 21"/>
+          <p:cNvSpPr txBox="1"/>
+          <p:nvPr/>
+        </p:nvSpPr>
+        <p:spPr>
+          <a:xfrm>
+            <a:off x="731520" y="6510528"/>
+            <a:ext cx="10725912" cy="228600"/>
+          </a:xfrm>
+          <a:prstGeom prst="rect">
+            <a:avLst/>
+          </a:prstGeom>
+        </p:spPr>
+        <p:txBody>
+          <a:bodyPr anchor="t"/>
+          <a:lstStyle/>
+          <a:p>
+            <a:pPr algn="ctr"/>
+            <a:r>
+              <a:rPr i="1" sz="800">
+                <a:solidFill>
+                  <a:srgbClr val="94A3B8"/>
+                </a:solidFill>
+                <a:latin typeface="+mn-lt"/>
+                <a:cs typeface="+mn-lt"/>
+              </a:rPr>
+              <a:t>* Disclaimer: All benchmark metrics, performance figures, and simulated architectures in this deck are synthetic demonstration values generated solely to showcase the authoring, formatting, and rendering capabilities of @hokkyss/pptx.</a:t>
+            </a:r>
+          </a:p>
+        </p:txBody>
+      </p:sp>
+    </p:spTree>
+  </p:cSld>
+  <p:clrMapOvr>
+    <a:masterClrMapping/>
+  </p:clrMapOvr>
+  <p:transition spd="fast">
+    <p:fade/>
+  </p:transition>
+  <p:timing>
+    <p:tnLst>
+      <p:par>
+        <p:cTn dur="indefinite" id="1" nodeType="tmRoot" restart="never">
+          <p:childTnLst>
+            <p:seq concurrent="1" nextAc="seek">
+              <p:cTn dur="indefinite" id="2" nodeType="mainSeq">
+                <p:childTnLst>
+                  <p:video>
+                    <p:cMediaNode vol="0">
+                      <p:cTn dur="indefinite" id="5" nodeType="withEffect" restart="never" repeatCount="indefinite">
+                        <p:stCondLst>
+                          <p:cond delay="0"/>
+                        </p:stCondLst>
+                        <p:endCondLst>
+                          <p:cond delay="0" evt="onStopAudio"/>
+                        </p:endCondLst>
+                      </p:cTn>
+                      <p:tgtEl>
+                        <p:spTgt spid="18"/>
+                      </p:tgtEl>
+                    </p:cMediaNode>
+                  </p:video>
+                </p:childTnLst>
+              </p:cTn>
+            </p:seq>
+            <p:seq concurrent="1" nextAc="seek">
+              <p:cTn evtFilter="cancelBubble" fill="hold" id="4" nodeType="interactiveSeq" restart="whenNotActive">
+                <p:stCondLst>
+                  <p:cond delay="0" evt="onClick">
+                    <p:tgtEl>
+                      <p:spTgt spid="10"/>
+                    </p:tgtEl>
+                  </p:cond>
+                </p:stCondLst>
+                <p:childTnLst>
+                  <p:audio>
+                    <p:cMediaNode vol="80000">
+                      <p:cTn dur="indefinite" id="3" nodeType="clickEffect" restart="never" repeatCount="indefinite">
+                        <p:stCondLst>
+                          <p:cond delay="0"/>
+                        </p:stCondLst>
+                        <p:endCondLst>
+                          <p:cond delay="0" evt="onStopAudio"/>
+                        </p:endCondLst>
+                      </p:cTn>
+                      <p:tgtEl>
+                        <p:spTgt spid="10"/>
+                      </p:tgtEl>
+                    </p:cMediaNode>
+                  </p:audio>
+                </p:childTnLst>
+              </p:cTn>
+            </p:seq>
+          </p:childTnLst>
+        </p:cTn>
+      </p:par>
+    </p:tnLst>
+  </p:timing>
+</p:sld>
+</file>
+
+<file path=ppt/slides/slide17.xml><?xml version="1.0" encoding="utf-8"?>
 <p:sld xmlns:a="http://schemas.openxmlformats.org/drawingml/2006/main" xmlns:p="http://schemas.openxmlformats.org/presentationml/2006/main" xmlns:r="http://schemas.openxmlformats.org/officeDocument/2006/relationships">
   <p:cSld>
     <p:bg>

</xml_diff>